<commit_message>
Apresentação: casos de uso do Jev
</commit_message>
<xml_diff>
--- a/docs/workshop-jev-apresentacao.pptx
+++ b/docs/workshop-jev-apresentacao.pptx
@@ -46,9 +46,13 @@
     <p:sldId id="294" r:id="rId40"/>
     <p:sldId id="295" r:id="rId41"/>
     <p:sldId id="296" r:id="rId42"/>
+    <p:sldId id="297" r:id="rId43"/>
+    <p:sldId id="298" r:id="rId44"/>
+    <p:sldId id="299" r:id="rId45"/>
+    <p:sldId id="300" r:id="rId46"/>
   </p:sldIdLst>
   <p:notesMasterIdLst>
-    <p:notesMasterId r:id="rId43"/>
+    <p:notesMasterId r:id="rId47"/>
   </p:notesMasterIdLst>
   <p:sldSz cx="12192000" cy="6858000"/>
   <p:notesSz cx="6858000" cy="12192000"/>
@@ -3696,12 +3700,7 @@
           <a:p>
             <a:r>
               <a:rPr lang="en-US" dirty="0"/>
-              <a:t>Itens que o laboratório deixou abertos, para quem quiser continuar:
-- fechar a validação da v3 no split de teste (22 de 100 feitos);
-- rodar em ~300 redações para uma métrica estável;
-- a camada de feedback em texto (decidir o produto antes do código);
-- Open-Jev self-hosted (modelos 2B/9B/27B em Docker, sem custo por chamada, mas precisa de GPU).
-Lembre a turma: a chave de hoje será revogada.</a:t>
+              <a:t>Transição para os casos de uso. A mensagem: a redação foi só o laboratório; o que a turma aprendeu é um padrão de produto.</a:t>
             </a:r>
             <a:endParaRPr lang="en-US" dirty="0"/>
           </a:p>
@@ -3725,6 +3724,371 @@
             <a:fld id="{F7021451-1387-4CA6-816F-3879F97B5CBC}" type="slidenum">
               <a:rPr lang="en-US"/>
               <a:t>41</a:t>
+            </a:fld>
+            <a:endParaRPr lang="en-US"/>
+          </a:p>
+        </p:txBody>
+      </p:sp>
+    </p:spTree>
+    <p:extLst>
+      <p:ext uri="{BB962C8B-B14F-4D97-AF65-F5344CB8AC3E}">
+        <p14:creationId xmlns:p14="http://schemas.microsoft.com/office/powerpoint/2010/main" val="1024086991"/>
+      </p:ext>
+    </p:extLst>
+  </p:cSld>
+  <p:clrMapOvr>
+    <a:masterClrMapping/>
+  </p:clrMapOvr>
+</p:notes>
+</file>
+
+<file path=ppt/notesSlides/notesSlide42.xml><?xml version="1.0" encoding="utf-8"?>
+<p:notes xmlns:a="http://schemas.openxmlformats.org/drawingml/2006/main" xmlns:r="http://schemas.openxmlformats.org/officeDocument/2006/relationships" xmlns:p="http://schemas.openxmlformats.org/presentationml/2006/main">
+  <p:cSld>
+    <p:spTree>
+      <p:nvGrpSpPr>
+        <p:cNvPr id="1" name=""/>
+        <p:cNvGrpSpPr/>
+        <p:nvPr/>
+      </p:nvGrpSpPr>
+      <p:grpSpPr>
+        <a:xfrm>
+          <a:off x="0" y="0"/>
+          <a:ext cx="0" cy="0"/>
+          <a:chOff x="0" y="0"/>
+          <a:chExt cx="0" cy="0"/>
+        </a:xfrm>
+      </p:grpSpPr>
+      <p:sp>
+        <p:nvSpPr>
+          <p:cNvPr id="2" name="Slide Image Placeholder 1"/>
+          <p:cNvSpPr>
+            <a:spLocks noGrp="1" noRot="1" noChangeAspect="1"/>
+          </p:cNvSpPr>
+          <p:nvPr>
+            <p:ph type="sldImg"/>
+          </p:nvPr>
+        </p:nvSpPr>
+        <p:spPr/>
+      </p:sp>
+      <p:sp>
+        <p:nvSpPr>
+          <p:cNvPr id="3" name="Notes Placeholder 2"/>
+          <p:cNvSpPr>
+            <a:spLocks noGrp="1"/>
+          </p:cNvSpPr>
+          <p:nvPr>
+            <p:ph type="body" idx="1"/>
+          </p:nvPr>
+        </p:nvSpPr>
+        <p:spPr/>
+        <p:txBody>
+          <a:bodyPr/>
+          <a:lstStyle/>
+          <a:p>
+            <a:r>
+              <a:rPr lang="en-US" dirty="0"/>
+              <a:t>O padrão que a turma acabou de construir, sem a redação.
+Qualquer processo que hoje é "uma pessoa lê alguma coisa e decide" cabe aqui: o texto vira o state, a regra de negócio vira as perguntas tipadas, e a confiança decide o que roda sozinho.
+A conta de dinheiro: o laboratório pagou US$ 0,000078 por avaliação (5 perguntas, ~1.850 tokens). Um milhão de avaliações nessa escala sai por cerca de US$ 78. Compare com o custo de uma pessoa lendo cada item.
+Seja honesto se perguntarem: custo cresce com o tamanho do texto, e a qualidade tem de ser medida em cada caso — como fizemos hoje.</a:t>
+            </a:r>
+            <a:endParaRPr lang="en-US" dirty="0"/>
+          </a:p>
+        </p:txBody>
+      </p:sp>
+      <p:sp>
+        <p:nvSpPr>
+          <p:cNvPr id="4" name="Slide Number Placeholder 3"/>
+          <p:cNvSpPr>
+            <a:spLocks noGrp="1"/>
+          </p:cNvSpPr>
+          <p:nvPr>
+            <p:ph type="sldNum" sz="quarter" idx="10"/>
+          </p:nvPr>
+        </p:nvSpPr>
+        <p:spPr/>
+        <p:txBody>
+          <a:bodyPr/>
+          <a:lstStyle/>
+          <a:p>
+            <a:fld id="{F7021451-1387-4CA6-816F-3879F97B5CBC}" type="slidenum">
+              <a:rPr lang="en-US"/>
+              <a:t>42</a:t>
+            </a:fld>
+            <a:endParaRPr lang="en-US"/>
+          </a:p>
+        </p:txBody>
+      </p:sp>
+    </p:spTree>
+    <p:extLst>
+      <p:ext uri="{BB962C8B-B14F-4D97-AF65-F5344CB8AC3E}">
+        <p14:creationId xmlns:p14="http://schemas.microsoft.com/office/powerpoint/2010/main" val="1024086991"/>
+      </p:ext>
+    </p:extLst>
+  </p:cSld>
+  <p:clrMapOvr>
+    <a:masterClrMapping/>
+  </p:clrMapOvr>
+</p:notes>
+</file>
+
+<file path=ppt/notesSlides/notesSlide43.xml><?xml version="1.0" encoding="utf-8"?>
+<p:notes xmlns:a="http://schemas.openxmlformats.org/drawingml/2006/main" xmlns:r="http://schemas.openxmlformats.org/officeDocument/2006/relationships" xmlns:p="http://schemas.openxmlformats.org/presentationml/2006/main">
+  <p:cSld>
+    <p:spTree>
+      <p:nvGrpSpPr>
+        <p:cNvPr id="1" name=""/>
+        <p:cNvGrpSpPr/>
+        <p:nvPr/>
+      </p:nvGrpSpPr>
+      <p:grpSpPr>
+        <a:xfrm>
+          <a:off x="0" y="0"/>
+          <a:ext cx="0" cy="0"/>
+          <a:chOff x="0" y="0"/>
+          <a:chExt cx="0" cy="0"/>
+        </a:xfrm>
+      </p:grpSpPr>
+      <p:sp>
+        <p:nvSpPr>
+          <p:cNvPr id="2" name="Slide Image Placeholder 1"/>
+          <p:cNvSpPr>
+            <a:spLocks noGrp="1" noRot="1" noChangeAspect="1"/>
+          </p:cNvSpPr>
+          <p:nvPr>
+            <p:ph type="sldImg"/>
+          </p:nvPr>
+        </p:nvSpPr>
+        <p:spPr/>
+      </p:sp>
+      <p:sp>
+        <p:nvSpPr>
+          <p:cNvPr id="3" name="Notes Placeholder 2"/>
+          <p:cNvSpPr>
+            <a:spLocks noGrp="1"/>
+          </p:cNvSpPr>
+          <p:nvPr>
+            <p:ph type="body" idx="1"/>
+          </p:nvPr>
+        </p:nvSpPr>
+        <p:spPr/>
+        <p:txBody>
+          <a:bodyPr/>
+          <a:lstStyle/>
+          <a:p>
+            <a:r>
+              <a:rPr lang="en-US" dirty="0"/>
+              <a:t>Seis exemplos, cada um com o tipo de pergunta que resolve. Peça à turma: "qual destes existe na empresa onde vocês trabalham ou querem trabalhar?".
+Destaque o guardrail de LLM: é o casamento dos dois tipos de IA do slide 5. O LLM generativo escreve; o Jev, rápido e barato, decide se aquilo pode sair. Sistema 2 cria, Sistema 1 confere.
+Todos seguem o mesmo roteiro de hoje: escrever a rubrica, medir contra humanos com baseline, ajustar a régua e escolher o limiar de confiança.
+Os exemplos são ilustrativos: não foram medidos no laboratório. O que foi medido é o método.</a:t>
+            </a:r>
+            <a:endParaRPr lang="en-US" dirty="0"/>
+          </a:p>
+        </p:txBody>
+      </p:sp>
+      <p:sp>
+        <p:nvSpPr>
+          <p:cNvPr id="4" name="Slide Number Placeholder 3"/>
+          <p:cNvSpPr>
+            <a:spLocks noGrp="1"/>
+          </p:cNvSpPr>
+          <p:nvPr>
+            <p:ph type="sldNum" sz="quarter" idx="10"/>
+          </p:nvPr>
+        </p:nvSpPr>
+        <p:spPr/>
+        <p:txBody>
+          <a:bodyPr/>
+          <a:lstStyle/>
+          <a:p>
+            <a:fld id="{F7021451-1387-4CA6-816F-3879F97B5CBC}" type="slidenum">
+              <a:rPr lang="en-US"/>
+              <a:t>43</a:t>
+            </a:fld>
+            <a:endParaRPr lang="en-US"/>
+          </a:p>
+        </p:txBody>
+      </p:sp>
+    </p:spTree>
+    <p:extLst>
+      <p:ext uri="{BB962C8B-B14F-4D97-AF65-F5344CB8AC3E}">
+        <p14:creationId xmlns:p14="http://schemas.microsoft.com/office/powerpoint/2010/main" val="1024086991"/>
+      </p:ext>
+    </p:extLst>
+  </p:cSld>
+  <p:clrMapOvr>
+    <a:masterClrMapping/>
+  </p:clrMapOvr>
+</p:notes>
+</file>
+
+<file path=ppt/notesSlides/notesSlide44.xml><?xml version="1.0" encoding="utf-8"?>
+<p:notes xmlns:a="http://schemas.openxmlformats.org/drawingml/2006/main" xmlns:r="http://schemas.openxmlformats.org/officeDocument/2006/relationships" xmlns:p="http://schemas.openxmlformats.org/presentationml/2006/main">
+  <p:cSld>
+    <p:spTree>
+      <p:nvGrpSpPr>
+        <p:cNvPr id="1" name=""/>
+        <p:cNvGrpSpPr/>
+        <p:nvPr/>
+      </p:nvGrpSpPr>
+      <p:grpSpPr>
+        <a:xfrm>
+          <a:off x="0" y="0"/>
+          <a:ext cx="0" cy="0"/>
+          <a:chOff x="0" y="0"/>
+          <a:chExt cx="0" cy="0"/>
+        </a:xfrm>
+      </p:grpSpPr>
+      <p:sp>
+        <p:nvSpPr>
+          <p:cNvPr id="2" name="Slide Image Placeholder 1"/>
+          <p:cNvSpPr>
+            <a:spLocks noGrp="1" noRot="1" noChangeAspect="1"/>
+          </p:cNvSpPr>
+          <p:nvPr>
+            <p:ph type="sldImg"/>
+          </p:nvPr>
+        </p:nvSpPr>
+        <p:spPr/>
+      </p:sp>
+      <p:sp>
+        <p:nvSpPr>
+          <p:cNvPr id="3" name="Notes Placeholder 2"/>
+          <p:cNvSpPr>
+            <a:spLocks noGrp="1"/>
+          </p:cNvSpPr>
+          <p:nvPr>
+            <p:ph type="body" idx="1"/>
+          </p:nvPr>
+        </p:nvSpPr>
+        <p:spPr/>
+        <p:txBody>
+          <a:bodyPr/>
+          <a:lstStyle/>
+          <a:p>
+            <a:r>
+              <a:rPr lang="en-US" dirty="0"/>
+              <a:t>Feche a parte de negócio ligando de volta ao workshop.
+Os seis pontos são as propriedades que fazem uma decisão automática ser vendável para uma empresa: integra no sistema, sabe quando não sabe, o negócio controla a regra, dá para auditar, o custo cabe na planilha, e há caminho para dados sensíveis.
+A última faixa é a frase para a turma levar: quem sabe medir, calibrar e escolher o limiar é quem coloca IA em produção — e é essa a habilidade que o mercado paga.</a:t>
+            </a:r>
+            <a:endParaRPr lang="en-US" dirty="0"/>
+          </a:p>
+        </p:txBody>
+      </p:sp>
+      <p:sp>
+        <p:nvSpPr>
+          <p:cNvPr id="4" name="Slide Number Placeholder 3"/>
+          <p:cNvSpPr>
+            <a:spLocks noGrp="1"/>
+          </p:cNvSpPr>
+          <p:nvPr>
+            <p:ph type="sldNum" sz="quarter" idx="10"/>
+          </p:nvPr>
+        </p:nvSpPr>
+        <p:spPr/>
+        <p:txBody>
+          <a:bodyPr/>
+          <a:lstStyle/>
+          <a:p>
+            <a:fld id="{F7021451-1387-4CA6-816F-3879F97B5CBC}" type="slidenum">
+              <a:rPr lang="en-US"/>
+              <a:t>44</a:t>
+            </a:fld>
+            <a:endParaRPr lang="en-US"/>
+          </a:p>
+        </p:txBody>
+      </p:sp>
+    </p:spTree>
+    <p:extLst>
+      <p:ext uri="{BB962C8B-B14F-4D97-AF65-F5344CB8AC3E}">
+        <p14:creationId xmlns:p14="http://schemas.microsoft.com/office/powerpoint/2010/main" val="1024086991"/>
+      </p:ext>
+    </p:extLst>
+  </p:cSld>
+  <p:clrMapOvr>
+    <a:masterClrMapping/>
+  </p:clrMapOvr>
+</p:notes>
+</file>
+
+<file path=ppt/notesSlides/notesSlide45.xml><?xml version="1.0" encoding="utf-8"?>
+<p:notes xmlns:a="http://schemas.openxmlformats.org/drawingml/2006/main" xmlns:r="http://schemas.openxmlformats.org/officeDocument/2006/relationships" xmlns:p="http://schemas.openxmlformats.org/presentationml/2006/main">
+  <p:cSld>
+    <p:spTree>
+      <p:nvGrpSpPr>
+        <p:cNvPr id="1" name=""/>
+        <p:cNvGrpSpPr/>
+        <p:nvPr/>
+      </p:nvGrpSpPr>
+      <p:grpSpPr>
+        <a:xfrm>
+          <a:off x="0" y="0"/>
+          <a:ext cx="0" cy="0"/>
+          <a:chOff x="0" y="0"/>
+          <a:chExt cx="0" cy="0"/>
+        </a:xfrm>
+      </p:grpSpPr>
+      <p:sp>
+        <p:nvSpPr>
+          <p:cNvPr id="2" name="Slide Image Placeholder 1"/>
+          <p:cNvSpPr>
+            <a:spLocks noGrp="1" noRot="1" noChangeAspect="1"/>
+          </p:cNvSpPr>
+          <p:nvPr>
+            <p:ph type="sldImg"/>
+          </p:nvPr>
+        </p:nvSpPr>
+        <p:spPr/>
+      </p:sp>
+      <p:sp>
+        <p:nvSpPr>
+          <p:cNvPr id="3" name="Notes Placeholder 2"/>
+          <p:cNvSpPr>
+            <a:spLocks noGrp="1"/>
+          </p:cNvSpPr>
+          <p:nvPr>
+            <p:ph type="body" idx="1"/>
+          </p:nvPr>
+        </p:nvSpPr>
+        <p:spPr/>
+        <p:txBody>
+          <a:bodyPr/>
+          <a:lstStyle/>
+          <a:p>
+            <a:r>
+              <a:rPr lang="en-US" dirty="0"/>
+              <a:t>Itens que o laboratório deixou abertos, para quem quiser continuar:
+- fechar a validação da v3 no split de teste (22 de 100 feitos);
+- rodar em ~300 redações para uma métrica estável;
+- a camada de feedback em texto (decidir o produto antes do código);
+- Open-Jev self-hosted (modelos 2B/9B/27B em Docker, sem custo por chamada, mas precisa de GPU).
+Lembre a turma: a chave de hoje será revogada.</a:t>
+            </a:r>
+            <a:endParaRPr lang="en-US" dirty="0"/>
+          </a:p>
+        </p:txBody>
+      </p:sp>
+      <p:sp>
+        <p:nvSpPr>
+          <p:cNvPr id="4" name="Slide Number Placeholder 3"/>
+          <p:cNvSpPr>
+            <a:spLocks noGrp="1"/>
+          </p:cNvSpPr>
+          <p:nvPr>
+            <p:ph type="sldNum" sz="quarter" idx="10"/>
+          </p:nvPr>
+        </p:nvSpPr>
+        <p:spPr/>
+        <p:txBody>
+          <a:bodyPr/>
+          <a:lstStyle/>
+          <a:p>
+            <a:fld id="{F7021451-1387-4CA6-816F-3879F97B5CBC}" type="slidenum">
+              <a:rPr lang="en-US"/>
+              <a:t>45</a:t>
             </a:fld>
             <a:endParaRPr lang="en-US"/>
           </a:p>
@@ -41186,6 +41550,4022 @@
   <p:cSld name="Slide 41">
     <p:bg>
       <p:bgPr>
+        <a:solidFill>
+          <a:srgbClr val="5922A5"/>
+        </a:solidFill>
+      </p:bgPr>
+    </p:bg>
+    <p:spTree>
+      <p:nvGrpSpPr>
+        <p:cNvPr id="1" name=""/>
+        <p:cNvGrpSpPr/>
+        <p:nvPr/>
+      </p:nvGrpSpPr>
+      <p:grpSpPr>
+        <a:xfrm>
+          <a:off x="0" y="0"/>
+          <a:ext cx="0" cy="0"/>
+          <a:chOff x="0" y="0"/>
+          <a:chExt cx="0" cy="0"/>
+        </a:xfrm>
+      </p:grpSpPr>
+      <p:sp>
+        <p:nvSpPr>
+          <p:cNvPr id="2" name="Text 0"/>
+          <p:cNvSpPr txBox="1"/>
+          <p:nvPr/>
+        </p:nvSpPr>
+        <p:spPr>
+          <a:xfrm>
+            <a:off x="548640" y="1234440"/>
+            <a:ext cx="3657600" cy="1371600"/>
+          </a:xfrm>
+          <a:prstGeom prst="rect">
+            <a:avLst/>
+          </a:prstGeom>
+          <a:noFill/>
+          <a:ln/>
+        </p:spPr>
+        <p:txBody>
+          <a:bodyPr wrap="square" lIns="0" tIns="0" rIns="0" bIns="0" rtlCol="0" anchor="t"/>
+          <a:lstStyle/>
+          <a:p>
+            <a:pPr indent="0" marL="0">
+              <a:buNone/>
+            </a:pPr>
+            <a:r>
+              <a:rPr lang="en-US" sz="9600" b="1" dirty="0">
+                <a:solidFill>
+                  <a:srgbClr val="FFC31A"/>
+                </a:solidFill>
+                <a:latin typeface="Montserrat" pitchFamily="34" charset="0"/>
+                <a:ea typeface="Montserrat" pitchFamily="34" charset="-122"/>
+                <a:cs typeface="Montserrat" pitchFamily="34" charset="-120"/>
+              </a:rPr>
+              <a:t>03</a:t>
+            </a:r>
+            <a:endParaRPr lang="en-US" sz="9600" dirty="0"/>
+          </a:p>
+        </p:txBody>
+      </p:sp>
+      <p:sp>
+        <p:nvSpPr>
+          <p:cNvPr id="3" name="Text 0"/>
+          <p:cNvSpPr/>
+          <p:nvPr>
+            <p:ph idx="100" type="title" hasCustomPrompt="1"/>
+          </p:nvPr>
+        </p:nvSpPr>
+        <p:spPr>
+          <a:xfrm>
+            <a:off x="548640" y="2743200"/>
+            <a:ext cx="10058400" cy="1188720"/>
+          </a:xfrm>
+          <a:prstGeom prst="rect">
+            <a:avLst/>
+          </a:prstGeom>
+          <a:noFill/>
+          <a:ln/>
+        </p:spPr>
+        <p:txBody>
+          <a:bodyPr wrap="square" lIns="0" tIns="0" rIns="0" bIns="0" rtlCol="0" anchor="ctr"/>
+          <a:lstStyle/>
+          <a:p>
+            <a:pPr algn="l" indent="0" marL="0">
+              <a:buNone/>
+            </a:pPr>
+            <a:r>
+              <a:rPr lang="en-US" sz="4800" b="1" dirty="0">
+                <a:solidFill>
+                  <a:srgbClr val="FFFFFF"/>
+                </a:solidFill>
+                <a:latin typeface="Montserrat" pitchFamily="34" charset="0"/>
+                <a:ea typeface="Montserrat" pitchFamily="34" charset="-122"/>
+                <a:cs typeface="Montserrat" pitchFamily="34" charset="-120"/>
+              </a:rPr>
+              <a:t>Onde o Jev vira dinheiro</a:t>
+            </a:r>
+            <a:endParaRPr lang="en-US" sz="4800" dirty="0"/>
+          </a:p>
+        </p:txBody>
+      </p:sp>
+      <p:sp>
+        <p:nvSpPr>
+          <p:cNvPr id="4" name="Text 2"/>
+          <p:cNvSpPr txBox="1"/>
+          <p:nvPr/>
+        </p:nvSpPr>
+        <p:spPr>
+          <a:xfrm>
+            <a:off x="548640" y="4069080"/>
+            <a:ext cx="8686800" cy="914400"/>
+          </a:xfrm>
+          <a:prstGeom prst="rect">
+            <a:avLst/>
+          </a:prstGeom>
+          <a:noFill/>
+          <a:ln/>
+        </p:spPr>
+        <p:txBody>
+          <a:bodyPr wrap="square" lIns="0" tIns="0" rIns="0" bIns="0" rtlCol="0" anchor="t"/>
+          <a:lstStyle/>
+          <a:p>
+            <a:pPr indent="0" marL="0">
+              <a:buNone/>
+            </a:pPr>
+            <a:r>
+              <a:rPr lang="en-US" sz="2000" dirty="0">
+                <a:solidFill>
+                  <a:srgbClr val="E4DAF7"/>
+                </a:solidFill>
+                <a:latin typeface="Montserrat" pitchFamily="34" charset="0"/>
+                <a:ea typeface="Montserrat" pitchFamily="34" charset="-122"/>
+                <a:cs typeface="Montserrat" pitchFamily="34" charset="-120"/>
+              </a:rPr>
+              <a:t>O toy problem acabou. O mesmo padrão vale para qualquer decisão repetitiva que hoje custa horas de gente.</a:t>
+            </a:r>
+            <a:endParaRPr lang="en-US" sz="2000" dirty="0"/>
+          </a:p>
+        </p:txBody>
+      </p:sp>
+      <p:pic>
+        <p:nvPicPr>
+          <p:cNvPr id="5" name="Image 0" descr="/home/claude/deck/assets/logo-branco.png">    </p:cNvPr>
+          <p:cNvPicPr>
+            <a:picLocks noChangeAspect="1"/>
+          </p:cNvPicPr>
+          <p:nvPr/>
+        </p:nvPicPr>
+        <p:blipFill>
+          <a:blip r:embed="rId1"/>
+          <a:stretch>
+            <a:fillRect/>
+          </a:stretch>
+        </p:blipFill>
+        <p:spPr>
+          <a:xfrm>
+            <a:off x="10241280" y="5989320"/>
+            <a:ext cx="1417320" cy="533579"/>
+          </a:xfrm>
+          <a:prstGeom prst="rect">
+            <a:avLst/>
+          </a:prstGeom>
+        </p:spPr>
+      </p:pic>
+    </p:spTree>
+  </p:cSld>
+  <p:clrMapOvr>
+    <a:masterClrMapping/>
+  </p:clrMapOvr>
+</p:sld>
+</file>
+
+<file path=ppt/slides/slide42.xml><?xml version="1.0" encoding="utf-8"?>
+<p:sld xmlns:a="http://schemas.openxmlformats.org/drawingml/2006/main" xmlns:r="http://schemas.openxmlformats.org/officeDocument/2006/relationships" xmlns:p="http://schemas.openxmlformats.org/presentationml/2006/main">
+  <p:cSld name="Slide 42">
+    <p:bg>
+      <p:bgPr>
+        <a:solidFill>
+          <a:srgbClr val="FAFAFA"/>
+        </a:solidFill>
+      </p:bgPr>
+    </p:bg>
+    <p:spTree>
+      <p:nvGrpSpPr>
+        <p:cNvPr id="1" name=""/>
+        <p:cNvGrpSpPr/>
+        <p:nvPr/>
+      </p:nvGrpSpPr>
+      <p:grpSpPr>
+        <a:xfrm>
+          <a:off x="0" y="0"/>
+          <a:ext cx="0" cy="0"/>
+          <a:chOff x="0" y="0"/>
+          <a:chExt cx="0" cy="0"/>
+        </a:xfrm>
+      </p:grpSpPr>
+      <p:sp>
+        <p:nvSpPr>
+          <p:cNvPr id="2" name="Text 0"/>
+          <p:cNvSpPr txBox="1"/>
+          <p:nvPr/>
+        </p:nvSpPr>
+        <p:spPr>
+          <a:xfrm>
+            <a:off x="548640" y="365760"/>
+            <a:ext cx="8229600" cy="274320"/>
+          </a:xfrm>
+          <a:prstGeom prst="rect">
+            <a:avLst/>
+          </a:prstGeom>
+          <a:noFill/>
+          <a:ln/>
+        </p:spPr>
+        <p:txBody>
+          <a:bodyPr wrap="square" lIns="0" tIns="0" rIns="0" bIns="0" rtlCol="0" anchor="t"/>
+          <a:lstStyle/>
+          <a:p>
+            <a:pPr indent="0" marL="0">
+              <a:buNone/>
+            </a:pPr>
+            <a:r>
+              <a:rPr lang="en-US" sz="1200" b="1" spc="200" kern="0" dirty="0">
+                <a:solidFill>
+                  <a:srgbClr val="5922A5"/>
+                </a:solidFill>
+                <a:latin typeface="Montserrat" pitchFamily="34" charset="0"/>
+                <a:ea typeface="Montserrat" pitchFamily="34" charset="-122"/>
+                <a:cs typeface="Montserrat" pitchFamily="34" charset="-120"/>
+              </a:rPr>
+              <a:t>CASOS DE USO · O PADRÃO</a:t>
+            </a:r>
+            <a:endParaRPr lang="en-US" sz="1200" dirty="0"/>
+          </a:p>
+        </p:txBody>
+      </p:sp>
+      <p:sp>
+        <p:nvSpPr>
+          <p:cNvPr id="3" name="Text 0"/>
+          <p:cNvSpPr/>
+          <p:nvPr>
+            <p:ph idx="100" type="title" hasCustomPrompt="1"/>
+          </p:nvPr>
+        </p:nvSpPr>
+        <p:spPr>
+          <a:xfrm>
+            <a:off x="548640" y="658368"/>
+            <a:ext cx="9692640" cy="685800"/>
+          </a:xfrm>
+          <a:prstGeom prst="rect">
+            <a:avLst/>
+          </a:prstGeom>
+          <a:noFill/>
+          <a:ln/>
+        </p:spPr>
+        <p:txBody>
+          <a:bodyPr wrap="square" lIns="0" tIns="0" rIns="0" bIns="0" rtlCol="0" anchor="ctr"/>
+          <a:lstStyle/>
+          <a:p>
+            <a:pPr algn="l" indent="0" marL="0">
+              <a:buNone/>
+            </a:pPr>
+            <a:r>
+              <a:rPr lang="en-US" sz="3000" b="1" dirty="0">
+                <a:solidFill>
+                  <a:srgbClr val="0A0A0A"/>
+                </a:solidFill>
+                <a:latin typeface="Montserrat" pitchFamily="34" charset="0"/>
+                <a:ea typeface="Montserrat" pitchFamily="34" charset="-122"/>
+                <a:cs typeface="Montserrat" pitchFamily="34" charset="-120"/>
+              </a:rPr>
+              <a:t>Milhões de decisões pequenas, todo dia</a:t>
+            </a:r>
+            <a:endParaRPr lang="en-US" sz="3000" dirty="0"/>
+          </a:p>
+        </p:txBody>
+      </p:sp>
+      <p:pic>
+        <p:nvPicPr>
+          <p:cNvPr id="4" name="Image 0" descr="/home/claude/deck/assets/logo.png">    </p:cNvPr>
+          <p:cNvPicPr>
+            <a:picLocks noChangeAspect="1"/>
+          </p:cNvPicPr>
+          <p:nvPr/>
+        </p:nvPicPr>
+        <p:blipFill>
+          <a:blip r:embed="rId1"/>
+          <a:stretch>
+            <a:fillRect/>
+          </a:stretch>
+        </p:blipFill>
+        <p:spPr>
+          <a:xfrm>
+            <a:off x="10515600" y="384048"/>
+            <a:ext cx="1143000" cy="430306"/>
+          </a:xfrm>
+          <a:prstGeom prst="rect">
+            <a:avLst/>
+          </a:prstGeom>
+        </p:spPr>
+      </p:pic>
+      <p:sp>
+        <p:nvSpPr>
+          <p:cNvPr id="5" name="Text 2"/>
+          <p:cNvSpPr txBox="1"/>
+          <p:nvPr/>
+        </p:nvSpPr>
+        <p:spPr>
+          <a:xfrm>
+            <a:off x="548640" y="6419088"/>
+            <a:ext cx="5486400" cy="256032"/>
+          </a:xfrm>
+          <a:prstGeom prst="rect">
+            <a:avLst/>
+          </a:prstGeom>
+          <a:noFill/>
+          <a:ln/>
+        </p:spPr>
+        <p:txBody>
+          <a:bodyPr wrap="square" lIns="0" tIns="0" rIns="0" bIns="0" rtlCol="0" anchor="t"/>
+          <a:lstStyle/>
+          <a:p>
+            <a:pPr indent="0" marL="0">
+              <a:buNone/>
+            </a:pPr>
+            <a:r>
+              <a:rPr lang="en-US" sz="1000" dirty="0">
+                <a:solidFill>
+                  <a:srgbClr val="6B7280"/>
+                </a:solidFill>
+                <a:latin typeface="Montserrat" pitchFamily="34" charset="0"/>
+                <a:ea typeface="Montserrat" pitchFamily="34" charset="-122"/>
+                <a:cs typeface="Montserrat" pitchFamily="34" charset="-120"/>
+              </a:rPr>
+              <a:t>Workshop JEV · WebTech Network</a:t>
+            </a:r>
+            <a:endParaRPr lang="en-US" sz="1000" dirty="0"/>
+          </a:p>
+        </p:txBody>
+      </p:sp>
+      <p:sp>
+        <p:nvSpPr>
+          <p:cNvPr id="6" name="Text 3"/>
+          <p:cNvSpPr txBox="1"/>
+          <p:nvPr/>
+        </p:nvSpPr>
+        <p:spPr>
+          <a:xfrm>
+            <a:off x="11091672" y="6419088"/>
+            <a:ext cx="548640" cy="256032"/>
+          </a:xfrm>
+          <a:prstGeom prst="rect">
+            <a:avLst/>
+          </a:prstGeom>
+          <a:noFill/>
+          <a:ln/>
+        </p:spPr>
+        <p:txBody>
+          <a:bodyPr wrap="square" lIns="0" tIns="0" rIns="0" bIns="0" rtlCol="0" anchor="t"/>
+          <a:lstStyle/>
+          <a:p>
+            <a:pPr algn="r" indent="0" marL="0">
+              <a:buNone/>
+            </a:pPr>
+            <a:r>
+              <a:rPr lang="en-US" sz="1000" dirty="0">
+                <a:solidFill>
+                  <a:srgbClr val="6B7280"/>
+                </a:solidFill>
+                <a:latin typeface="Montserrat" pitchFamily="34" charset="0"/>
+                <a:ea typeface="Montserrat" pitchFamily="34" charset="-122"/>
+                <a:cs typeface="Montserrat" pitchFamily="34" charset="-120"/>
+              </a:rPr>
+              <a:t>42</a:t>
+            </a:r>
+            <a:endParaRPr lang="en-US" sz="1000" dirty="0"/>
+          </a:p>
+        </p:txBody>
+      </p:sp>
+      <p:sp>
+        <p:nvSpPr>
+          <p:cNvPr id="7" name="Shape 4"/>
+          <p:cNvSpPr/>
+          <p:nvPr/>
+        </p:nvSpPr>
+        <p:spPr>
+          <a:xfrm>
+            <a:off x="548640" y="1691640"/>
+            <a:ext cx="2578608" cy="1828800"/>
+          </a:xfrm>
+          <a:prstGeom prst="roundRect">
+            <a:avLst>
+              <a:gd name="adj" fmla="val 7000"/>
+            </a:avLst>
+          </a:prstGeom>
+          <a:solidFill>
+            <a:srgbClr val="FFFFFF"/>
+          </a:solidFill>
+          <a:ln w="12700">
+            <a:solidFill>
+              <a:srgbClr val="E5E7EB"/>
+            </a:solidFill>
+            <a:prstDash val="solid"/>
+          </a:ln>
+        </p:spPr>
+      </p:sp>
+      <p:sp>
+        <p:nvSpPr>
+          <p:cNvPr id="8" name="Text 5"/>
+          <p:cNvSpPr txBox="1"/>
+          <p:nvPr/>
+        </p:nvSpPr>
+        <p:spPr>
+          <a:xfrm>
+            <a:off x="822960" y="1801368"/>
+            <a:ext cx="2029968" cy="1609344"/>
+          </a:xfrm>
+          <a:prstGeom prst="rect">
+            <a:avLst/>
+          </a:prstGeom>
+          <a:noFill/>
+          <a:ln/>
+        </p:spPr>
+        <p:txBody>
+          <a:bodyPr wrap="square" lIns="0" tIns="0" rIns="0" bIns="0" rtlCol="0" anchor="ctr"/>
+          <a:lstStyle/>
+          <a:p>
+            <a:pPr algn="ctr" indent="0" marL="0">
+              <a:buNone/>
+            </a:pPr>
+            <a:r>
+              <a:rPr lang="en-US" sz="1700" b="1" dirty="0">
+                <a:solidFill>
+                  <a:srgbClr val="0A0A0A"/>
+                </a:solidFill>
+                <a:latin typeface="Montserrat" pitchFamily="34" charset="0"/>
+                <a:ea typeface="Montserrat" pitchFamily="34" charset="-122"/>
+                <a:cs typeface="Montserrat" pitchFamily="34" charset="-120"/>
+              </a:rPr>
+              <a:t>Estado</a:t>
+            </a:r>
+            <a:endParaRPr lang="en-US" sz="1300" dirty="0"/>
+          </a:p>
+          <a:p>
+            <a:pPr algn="ctr" indent="0" marL="0">
+              <a:buNone/>
+            </a:pPr>
+            <a:r>
+              <a:rPr lang="en-US" sz="800" dirty="0">
+                <a:solidFill>
+                  <a:srgbClr val="0A0A0A"/>
+                </a:solidFill>
+                <a:latin typeface="Montserrat" pitchFamily="34" charset="0"/>
+                <a:ea typeface="Montserrat" pitchFamily="34" charset="-122"/>
+                <a:cs typeface="Montserrat" pitchFamily="34" charset="-120"/>
+              </a:rPr>
+              <a:t> </a:t>
+            </a:r>
+            <a:endParaRPr lang="en-US" sz="1300" dirty="0"/>
+          </a:p>
+          <a:p>
+            <a:pPr algn="ctr" indent="0" marL="0">
+              <a:buNone/>
+            </a:pPr>
+            <a:r>
+              <a:rPr lang="en-US" sz="1300" dirty="0">
+                <a:solidFill>
+                  <a:srgbClr val="4B5563"/>
+                </a:solidFill>
+                <a:latin typeface="Montserrat" pitchFamily="34" charset="0"/>
+                <a:ea typeface="Montserrat" pitchFamily="34" charset="-122"/>
+                <a:cs typeface="Montserrat" pitchFamily="34" charset="-120"/>
+              </a:rPr>
+              <a:t>e-mail, ticket, contrato, transcrição, resposta de um agente</a:t>
+            </a:r>
+            <a:endParaRPr lang="en-US" sz="1300" dirty="0"/>
+          </a:p>
+        </p:txBody>
+      </p:sp>
+      <p:sp>
+        <p:nvSpPr>
+          <p:cNvPr id="9" name="Text 6"/>
+          <p:cNvSpPr txBox="1"/>
+          <p:nvPr/>
+        </p:nvSpPr>
+        <p:spPr>
+          <a:xfrm>
+            <a:off x="3127248" y="2331720"/>
+            <a:ext cx="256032" cy="548640"/>
+          </a:xfrm>
+          <a:prstGeom prst="rect">
+            <a:avLst/>
+          </a:prstGeom>
+          <a:noFill/>
+          <a:ln/>
+        </p:spPr>
+        <p:txBody>
+          <a:bodyPr wrap="square" lIns="0" tIns="0" rIns="0" bIns="0" rtlCol="0" anchor="ctr"/>
+          <a:lstStyle/>
+          <a:p>
+            <a:pPr algn="ctr" indent="0" marL="0">
+              <a:buNone/>
+            </a:pPr>
+            <a:r>
+              <a:rPr lang="en-US" sz="2000" b="1" dirty="0">
+                <a:solidFill>
+                  <a:srgbClr val="5922A5"/>
+                </a:solidFill>
+                <a:latin typeface="Montserrat" pitchFamily="34" charset="0"/>
+                <a:ea typeface="Montserrat" pitchFamily="34" charset="-122"/>
+                <a:cs typeface="Montserrat" pitchFamily="34" charset="-120"/>
+              </a:rPr>
+              <a:t>→</a:t>
+            </a:r>
+            <a:endParaRPr lang="en-US" sz="2000" dirty="0"/>
+          </a:p>
+        </p:txBody>
+      </p:sp>
+      <p:sp>
+        <p:nvSpPr>
+          <p:cNvPr id="10" name="Shape 7"/>
+          <p:cNvSpPr/>
+          <p:nvPr/>
+        </p:nvSpPr>
+        <p:spPr>
+          <a:xfrm>
+            <a:off x="3383280" y="1691640"/>
+            <a:ext cx="2578608" cy="1828800"/>
+          </a:xfrm>
+          <a:prstGeom prst="roundRect">
+            <a:avLst>
+              <a:gd name="adj" fmla="val 7000"/>
+            </a:avLst>
+          </a:prstGeom>
+          <a:solidFill>
+            <a:srgbClr val="5922A5"/>
+          </a:solidFill>
+          <a:ln w="12700">
+            <a:solidFill>
+              <a:srgbClr val="5922A5"/>
+            </a:solidFill>
+            <a:prstDash val="solid"/>
+          </a:ln>
+        </p:spPr>
+      </p:sp>
+      <p:sp>
+        <p:nvSpPr>
+          <p:cNvPr id="11" name="Text 8"/>
+          <p:cNvSpPr txBox="1"/>
+          <p:nvPr/>
+        </p:nvSpPr>
+        <p:spPr>
+          <a:xfrm>
+            <a:off x="3657600" y="1801368"/>
+            <a:ext cx="2029968" cy="1609344"/>
+          </a:xfrm>
+          <a:prstGeom prst="rect">
+            <a:avLst/>
+          </a:prstGeom>
+          <a:noFill/>
+          <a:ln/>
+        </p:spPr>
+        <p:txBody>
+          <a:bodyPr wrap="square" lIns="0" tIns="0" rIns="0" bIns="0" rtlCol="0" anchor="ctr"/>
+          <a:lstStyle/>
+          <a:p>
+            <a:pPr algn="ctr" indent="0" marL="0">
+              <a:buNone/>
+            </a:pPr>
+            <a:r>
+              <a:rPr lang="en-US" sz="1700" b="1" dirty="0">
+                <a:solidFill>
+                  <a:srgbClr val="FFC31A"/>
+                </a:solidFill>
+                <a:latin typeface="Montserrat" pitchFamily="34" charset="0"/>
+                <a:ea typeface="Montserrat" pitchFamily="34" charset="-122"/>
+                <a:cs typeface="Montserrat" pitchFamily="34" charset="-120"/>
+              </a:rPr>
+              <a:t>Perguntas tipadas</a:t>
+            </a:r>
+            <a:endParaRPr lang="en-US" sz="1300" dirty="0"/>
+          </a:p>
+          <a:p>
+            <a:pPr algn="ctr" indent="0" marL="0">
+              <a:buNone/>
+            </a:pPr>
+            <a:r>
+              <a:rPr lang="en-US" sz="800" dirty="0">
+                <a:solidFill>
+                  <a:srgbClr val="0A0A0A"/>
+                </a:solidFill>
+                <a:latin typeface="Montserrat" pitchFamily="34" charset="0"/>
+                <a:ea typeface="Montserrat" pitchFamily="34" charset="-122"/>
+                <a:cs typeface="Montserrat" pitchFamily="34" charset="-120"/>
+              </a:rPr>
+              <a:t> </a:t>
+            </a:r>
+            <a:endParaRPr lang="en-US" sz="1300" dirty="0"/>
+          </a:p>
+          <a:p>
+            <a:pPr algn="ctr" indent="0" marL="0">
+              <a:buNone/>
+            </a:pPr>
+            <a:r>
+              <a:rPr lang="en-US" sz="1300" dirty="0">
+                <a:solidFill>
+                  <a:srgbClr val="E4DAF7"/>
+                </a:solidFill>
+                <a:latin typeface="Montserrat" pitchFamily="34" charset="0"/>
+                <a:ea typeface="Montserrat" pitchFamily="34" charset="-122"/>
+                <a:cs typeface="Montserrat" pitchFamily="34" charset="-120"/>
+              </a:rPr>
+              <a:t>boolean · choice · score — várias numa chamada só</a:t>
+            </a:r>
+            <a:endParaRPr lang="en-US" sz="1300" dirty="0"/>
+          </a:p>
+        </p:txBody>
+      </p:sp>
+      <p:sp>
+        <p:nvSpPr>
+          <p:cNvPr id="12" name="Text 9"/>
+          <p:cNvSpPr txBox="1"/>
+          <p:nvPr/>
+        </p:nvSpPr>
+        <p:spPr>
+          <a:xfrm>
+            <a:off x="5961888" y="2331720"/>
+            <a:ext cx="256032" cy="548640"/>
+          </a:xfrm>
+          <a:prstGeom prst="rect">
+            <a:avLst/>
+          </a:prstGeom>
+          <a:noFill/>
+          <a:ln/>
+        </p:spPr>
+        <p:txBody>
+          <a:bodyPr wrap="square" lIns="0" tIns="0" rIns="0" bIns="0" rtlCol="0" anchor="ctr"/>
+          <a:lstStyle/>
+          <a:p>
+            <a:pPr algn="ctr" indent="0" marL="0">
+              <a:buNone/>
+            </a:pPr>
+            <a:r>
+              <a:rPr lang="en-US" sz="2000" b="1" dirty="0">
+                <a:solidFill>
+                  <a:srgbClr val="5922A5"/>
+                </a:solidFill>
+                <a:latin typeface="Montserrat" pitchFamily="34" charset="0"/>
+                <a:ea typeface="Montserrat" pitchFamily="34" charset="-122"/>
+                <a:cs typeface="Montserrat" pitchFamily="34" charset="-120"/>
+              </a:rPr>
+              <a:t>→</a:t>
+            </a:r>
+            <a:endParaRPr lang="en-US" sz="2000" dirty="0"/>
+          </a:p>
+        </p:txBody>
+      </p:sp>
+      <p:sp>
+        <p:nvSpPr>
+          <p:cNvPr id="13" name="Shape 10"/>
+          <p:cNvSpPr/>
+          <p:nvPr/>
+        </p:nvSpPr>
+        <p:spPr>
+          <a:xfrm>
+            <a:off x="6217920" y="1691640"/>
+            <a:ext cx="2578608" cy="1828800"/>
+          </a:xfrm>
+          <a:prstGeom prst="roundRect">
+            <a:avLst>
+              <a:gd name="adj" fmla="val 7000"/>
+            </a:avLst>
+          </a:prstGeom>
+          <a:solidFill>
+            <a:srgbClr val="EBE7F5"/>
+          </a:solidFill>
+          <a:ln w="12700">
+            <a:solidFill>
+              <a:srgbClr val="EBE7F5"/>
+            </a:solidFill>
+            <a:prstDash val="solid"/>
+          </a:ln>
+        </p:spPr>
+      </p:sp>
+      <p:sp>
+        <p:nvSpPr>
+          <p:cNvPr id="14" name="Text 11"/>
+          <p:cNvSpPr txBox="1"/>
+          <p:nvPr/>
+        </p:nvSpPr>
+        <p:spPr>
+          <a:xfrm>
+            <a:off x="6492240" y="1801368"/>
+            <a:ext cx="2029968" cy="1609344"/>
+          </a:xfrm>
+          <a:prstGeom prst="rect">
+            <a:avLst/>
+          </a:prstGeom>
+          <a:noFill/>
+          <a:ln/>
+        </p:spPr>
+        <p:txBody>
+          <a:bodyPr wrap="square" lIns="0" tIns="0" rIns="0" bIns="0" rtlCol="0" anchor="ctr"/>
+          <a:lstStyle/>
+          <a:p>
+            <a:pPr algn="ctr" indent="0" marL="0">
+              <a:buNone/>
+            </a:pPr>
+            <a:r>
+              <a:rPr lang="en-US" sz="1700" b="1" dirty="0">
+                <a:solidFill>
+                  <a:srgbClr val="5922A5"/>
+                </a:solidFill>
+                <a:latin typeface="Montserrat" pitchFamily="34" charset="0"/>
+                <a:ea typeface="Montserrat" pitchFamily="34" charset="-122"/>
+                <a:cs typeface="Montserrat" pitchFamily="34" charset="-120"/>
+              </a:rPr>
+              <a:t>Decisão + confiança</a:t>
+            </a:r>
+            <a:endParaRPr lang="en-US" sz="1300" dirty="0"/>
+          </a:p>
+          <a:p>
+            <a:pPr algn="ctr" indent="0" marL="0">
+              <a:buNone/>
+            </a:pPr>
+            <a:r>
+              <a:rPr lang="en-US" sz="800" dirty="0">
+                <a:solidFill>
+                  <a:srgbClr val="0A0A0A"/>
+                </a:solidFill>
+                <a:latin typeface="Montserrat" pitchFamily="34" charset="0"/>
+                <a:ea typeface="Montserrat" pitchFamily="34" charset="-122"/>
+                <a:cs typeface="Montserrat" pitchFamily="34" charset="-120"/>
+              </a:rPr>
+              <a:t> </a:t>
+            </a:r>
+            <a:endParaRPr lang="en-US" sz="1300" dirty="0"/>
+          </a:p>
+          <a:p>
+            <a:pPr algn="ctr" indent="0" marL="0">
+              <a:buNone/>
+            </a:pPr>
+            <a:r>
+              <a:rPr lang="en-US" sz="1300" dirty="0">
+                <a:solidFill>
+                  <a:srgbClr val="4B5563"/>
+                </a:solidFill>
+                <a:latin typeface="Montserrat" pitchFamily="34" charset="0"/>
+                <a:ea typeface="Montserrat" pitchFamily="34" charset="-122"/>
+                <a:cs typeface="Montserrat" pitchFamily="34" charset="-120"/>
+              </a:rPr>
+              <a:t>um valor que o código usa direto, com o grau de certeza</a:t>
+            </a:r>
+            <a:endParaRPr lang="en-US" sz="1300" dirty="0"/>
+          </a:p>
+        </p:txBody>
+      </p:sp>
+      <p:sp>
+        <p:nvSpPr>
+          <p:cNvPr id="15" name="Text 12"/>
+          <p:cNvSpPr txBox="1"/>
+          <p:nvPr/>
+        </p:nvSpPr>
+        <p:spPr>
+          <a:xfrm>
+            <a:off x="8796528" y="2331720"/>
+            <a:ext cx="256032" cy="548640"/>
+          </a:xfrm>
+          <a:prstGeom prst="rect">
+            <a:avLst/>
+          </a:prstGeom>
+          <a:noFill/>
+          <a:ln/>
+        </p:spPr>
+        <p:txBody>
+          <a:bodyPr wrap="square" lIns="0" tIns="0" rIns="0" bIns="0" rtlCol="0" anchor="ctr"/>
+          <a:lstStyle/>
+          <a:p>
+            <a:pPr algn="ctr" indent="0" marL="0">
+              <a:buNone/>
+            </a:pPr>
+            <a:r>
+              <a:rPr lang="en-US" sz="2000" b="1" dirty="0">
+                <a:solidFill>
+                  <a:srgbClr val="5922A5"/>
+                </a:solidFill>
+                <a:latin typeface="Montserrat" pitchFamily="34" charset="0"/>
+                <a:ea typeface="Montserrat" pitchFamily="34" charset="-122"/>
+                <a:cs typeface="Montserrat" pitchFamily="34" charset="-120"/>
+              </a:rPr>
+              <a:t>→</a:t>
+            </a:r>
+            <a:endParaRPr lang="en-US" sz="2000" dirty="0"/>
+          </a:p>
+        </p:txBody>
+      </p:sp>
+      <p:sp>
+        <p:nvSpPr>
+          <p:cNvPr id="16" name="Shape 13"/>
+          <p:cNvSpPr/>
+          <p:nvPr/>
+        </p:nvSpPr>
+        <p:spPr>
+          <a:xfrm>
+            <a:off x="9052560" y="1691640"/>
+            <a:ext cx="2578608" cy="1828800"/>
+          </a:xfrm>
+          <a:prstGeom prst="roundRect">
+            <a:avLst>
+              <a:gd name="adj" fmla="val 7000"/>
+            </a:avLst>
+          </a:prstGeom>
+          <a:solidFill>
+            <a:srgbClr val="FFC31A"/>
+          </a:solidFill>
+          <a:ln w="12700">
+            <a:solidFill>
+              <a:srgbClr val="FFC31A"/>
+            </a:solidFill>
+            <a:prstDash val="solid"/>
+          </a:ln>
+        </p:spPr>
+      </p:sp>
+      <p:sp>
+        <p:nvSpPr>
+          <p:cNvPr id="17" name="Text 14"/>
+          <p:cNvSpPr txBox="1"/>
+          <p:nvPr/>
+        </p:nvSpPr>
+        <p:spPr>
+          <a:xfrm>
+            <a:off x="9326880" y="1801368"/>
+            <a:ext cx="2029968" cy="1609344"/>
+          </a:xfrm>
+          <a:prstGeom prst="rect">
+            <a:avLst/>
+          </a:prstGeom>
+          <a:noFill/>
+          <a:ln/>
+        </p:spPr>
+        <p:txBody>
+          <a:bodyPr wrap="square" lIns="0" tIns="0" rIns="0" bIns="0" rtlCol="0" anchor="ctr"/>
+          <a:lstStyle/>
+          <a:p>
+            <a:pPr algn="ctr" indent="0" marL="0">
+              <a:buNone/>
+            </a:pPr>
+            <a:r>
+              <a:rPr lang="en-US" sz="1700" b="1" dirty="0">
+                <a:solidFill>
+                  <a:srgbClr val="0A0A0A"/>
+                </a:solidFill>
+                <a:latin typeface="Montserrat" pitchFamily="34" charset="0"/>
+                <a:ea typeface="Montserrat" pitchFamily="34" charset="-122"/>
+                <a:cs typeface="Montserrat" pitchFamily="34" charset="-120"/>
+              </a:rPr>
+              <a:t>Automatiza ou escala</a:t>
+            </a:r>
+            <a:endParaRPr lang="en-US" sz="1300" dirty="0"/>
+          </a:p>
+          <a:p>
+            <a:pPr algn="ctr" indent="0" marL="0">
+              <a:buNone/>
+            </a:pPr>
+            <a:r>
+              <a:rPr lang="en-US" sz="800" dirty="0">
+                <a:solidFill>
+                  <a:srgbClr val="0A0A0A"/>
+                </a:solidFill>
+                <a:latin typeface="Montserrat" pitchFamily="34" charset="0"/>
+                <a:ea typeface="Montserrat" pitchFamily="34" charset="-122"/>
+                <a:cs typeface="Montserrat" pitchFamily="34" charset="-120"/>
+              </a:rPr>
+              <a:t> </a:t>
+            </a:r>
+            <a:endParaRPr lang="en-US" sz="1300" dirty="0"/>
+          </a:p>
+          <a:p>
+            <a:pPr algn="ctr" indent="0" marL="0">
+              <a:buNone/>
+            </a:pPr>
+            <a:r>
+              <a:rPr lang="en-US" sz="1300" dirty="0">
+                <a:solidFill>
+                  <a:srgbClr val="4B5563"/>
+                </a:solidFill>
+                <a:latin typeface="Montserrat" pitchFamily="34" charset="0"/>
+                <a:ea typeface="Montserrat" pitchFamily="34" charset="-122"/>
+                <a:cs typeface="Montserrat" pitchFamily="34" charset="-120"/>
+              </a:rPr>
+              <a:t>confiança alta segue sozinha; baixa vai para um humano</a:t>
+            </a:r>
+            <a:endParaRPr lang="en-US" sz="1300" dirty="0"/>
+          </a:p>
+        </p:txBody>
+      </p:sp>
+      <p:sp>
+        <p:nvSpPr>
+          <p:cNvPr id="18" name="Shape 15"/>
+          <p:cNvSpPr/>
+          <p:nvPr/>
+        </p:nvSpPr>
+        <p:spPr>
+          <a:xfrm>
+            <a:off x="548640" y="3749040"/>
+            <a:ext cx="3547872" cy="1965960"/>
+          </a:xfrm>
+          <a:prstGeom prst="roundRect">
+            <a:avLst>
+              <a:gd name="adj" fmla="val 6512"/>
+            </a:avLst>
+          </a:prstGeom>
+          <a:solidFill>
+            <a:srgbClr val="FFFFFF"/>
+          </a:solidFill>
+          <a:ln w="12700">
+            <a:solidFill>
+              <a:srgbClr val="E5E7EB"/>
+            </a:solidFill>
+            <a:prstDash val="solid"/>
+          </a:ln>
+        </p:spPr>
+      </p:sp>
+      <p:sp>
+        <p:nvSpPr>
+          <p:cNvPr id="19" name="Text 16"/>
+          <p:cNvSpPr txBox="1"/>
+          <p:nvPr/>
+        </p:nvSpPr>
+        <p:spPr>
+          <a:xfrm>
+            <a:off x="822960" y="3858768"/>
+            <a:ext cx="2999232" cy="1746504"/>
+          </a:xfrm>
+          <a:prstGeom prst="rect">
+            <a:avLst/>
+          </a:prstGeom>
+          <a:noFill/>
+          <a:ln/>
+        </p:spPr>
+        <p:txBody>
+          <a:bodyPr wrap="square" lIns="0" tIns="0" rIns="0" bIns="0" rtlCol="0" anchor="ctr"/>
+          <a:lstStyle/>
+          <a:p>
+            <a:pPr indent="0" marL="0">
+              <a:buNone/>
+            </a:pPr>
+            <a:r>
+              <a:rPr lang="en-US" sz="4400" b="1" dirty="0">
+                <a:solidFill>
+                  <a:srgbClr val="5430BF"/>
+                </a:solidFill>
+                <a:latin typeface="Montserrat" pitchFamily="34" charset="0"/>
+                <a:ea typeface="Montserrat" pitchFamily="34" charset="-122"/>
+                <a:cs typeface="Montserrat" pitchFamily="34" charset="-120"/>
+              </a:rPr>
+              <a:t>~0,5 s</a:t>
+            </a:r>
+            <a:endParaRPr lang="en-US" sz="1400" dirty="0"/>
+          </a:p>
+          <a:p>
+            <a:pPr indent="0" marL="0">
+              <a:buNone/>
+            </a:pPr>
+            <a:r>
+              <a:rPr lang="en-US" sz="1400" dirty="0">
+                <a:solidFill>
+                  <a:srgbClr val="4B5563"/>
+                </a:solidFill>
+                <a:latin typeface="Montserrat" pitchFamily="34" charset="0"/>
+                <a:ea typeface="Montserrat" pitchFamily="34" charset="-122"/>
+                <a:cs typeface="Montserrat" pitchFamily="34" charset="-120"/>
+              </a:rPr>
+              <a:t>por decisão</a:t>
+            </a:r>
+            <a:endParaRPr lang="en-US" sz="1400" dirty="0"/>
+          </a:p>
+        </p:txBody>
+      </p:sp>
+      <p:sp>
+        <p:nvSpPr>
+          <p:cNvPr id="20" name="Shape 17"/>
+          <p:cNvSpPr/>
+          <p:nvPr/>
+        </p:nvSpPr>
+        <p:spPr>
+          <a:xfrm>
+            <a:off x="4315968" y="3749040"/>
+            <a:ext cx="3547872" cy="1965960"/>
+          </a:xfrm>
+          <a:prstGeom prst="roundRect">
+            <a:avLst>
+              <a:gd name="adj" fmla="val 6512"/>
+            </a:avLst>
+          </a:prstGeom>
+          <a:solidFill>
+            <a:srgbClr val="5922A5"/>
+          </a:solidFill>
+          <a:ln w="12700">
+            <a:solidFill>
+              <a:srgbClr val="5922A5"/>
+            </a:solidFill>
+            <a:prstDash val="solid"/>
+          </a:ln>
+        </p:spPr>
+      </p:sp>
+      <p:sp>
+        <p:nvSpPr>
+          <p:cNvPr id="21" name="Text 18"/>
+          <p:cNvSpPr txBox="1"/>
+          <p:nvPr/>
+        </p:nvSpPr>
+        <p:spPr>
+          <a:xfrm>
+            <a:off x="4590288" y="3858768"/>
+            <a:ext cx="2999232" cy="1746504"/>
+          </a:xfrm>
+          <a:prstGeom prst="rect">
+            <a:avLst/>
+          </a:prstGeom>
+          <a:noFill/>
+          <a:ln/>
+        </p:spPr>
+        <p:txBody>
+          <a:bodyPr wrap="square" lIns="0" tIns="0" rIns="0" bIns="0" rtlCol="0" anchor="ctr"/>
+          <a:lstStyle/>
+          <a:p>
+            <a:pPr indent="0" marL="0">
+              <a:buNone/>
+            </a:pPr>
+            <a:r>
+              <a:rPr lang="en-US" sz="4400" b="1" dirty="0">
+                <a:solidFill>
+                  <a:srgbClr val="FFC31A"/>
+                </a:solidFill>
+                <a:latin typeface="Montserrat" pitchFamily="34" charset="0"/>
+                <a:ea typeface="Montserrat" pitchFamily="34" charset="-122"/>
+                <a:cs typeface="Montserrat" pitchFamily="34" charset="-120"/>
+              </a:rPr>
+              <a:t>US$ 78</a:t>
+            </a:r>
+            <a:endParaRPr lang="en-US" sz="1400" dirty="0"/>
+          </a:p>
+          <a:p>
+            <a:pPr indent="0" marL="0">
+              <a:buNone/>
+            </a:pPr>
+            <a:r>
+              <a:rPr lang="en-US" sz="1400" dirty="0">
+                <a:solidFill>
+                  <a:srgbClr val="FFFFFF"/>
+                </a:solidFill>
+                <a:latin typeface="Montserrat" pitchFamily="34" charset="0"/>
+                <a:ea typeface="Montserrat" pitchFamily="34" charset="-122"/>
+                <a:cs typeface="Montserrat" pitchFamily="34" charset="-120"/>
+              </a:rPr>
+              <a:t>por 1 milhão de avaliações*</a:t>
+            </a:r>
+            <a:endParaRPr lang="en-US" sz="1400" dirty="0"/>
+          </a:p>
+        </p:txBody>
+      </p:sp>
+      <p:sp>
+        <p:nvSpPr>
+          <p:cNvPr id="22" name="Shape 19"/>
+          <p:cNvSpPr/>
+          <p:nvPr/>
+        </p:nvSpPr>
+        <p:spPr>
+          <a:xfrm>
+            <a:off x="8083296" y="3749040"/>
+            <a:ext cx="3547872" cy="1965960"/>
+          </a:xfrm>
+          <a:prstGeom prst="roundRect">
+            <a:avLst>
+              <a:gd name="adj" fmla="val 6512"/>
+            </a:avLst>
+          </a:prstGeom>
+          <a:solidFill>
+            <a:srgbClr val="FFFFFF"/>
+          </a:solidFill>
+          <a:ln w="12700">
+            <a:solidFill>
+              <a:srgbClr val="E5E7EB"/>
+            </a:solidFill>
+            <a:prstDash val="solid"/>
+          </a:ln>
+        </p:spPr>
+      </p:sp>
+      <p:sp>
+        <p:nvSpPr>
+          <p:cNvPr id="23" name="Text 20"/>
+          <p:cNvSpPr txBox="1"/>
+          <p:nvPr/>
+        </p:nvSpPr>
+        <p:spPr>
+          <a:xfrm>
+            <a:off x="8357616" y="3858768"/>
+            <a:ext cx="2999232" cy="1746504"/>
+          </a:xfrm>
+          <a:prstGeom prst="rect">
+            <a:avLst/>
+          </a:prstGeom>
+          <a:noFill/>
+          <a:ln/>
+        </p:spPr>
+        <p:txBody>
+          <a:bodyPr wrap="square" lIns="0" tIns="0" rIns="0" bIns="0" rtlCol="0" anchor="ctr"/>
+          <a:lstStyle/>
+          <a:p>
+            <a:pPr indent="0" marL="0">
+              <a:buNone/>
+            </a:pPr>
+            <a:r>
+              <a:rPr lang="en-US" sz="4400" b="1" dirty="0">
+                <a:solidFill>
+                  <a:srgbClr val="5430BF"/>
+                </a:solidFill>
+                <a:latin typeface="Montserrat" pitchFamily="34" charset="0"/>
+                <a:ea typeface="Montserrat" pitchFamily="34" charset="-122"/>
+                <a:cs typeface="Montserrat" pitchFamily="34" charset="-120"/>
+              </a:rPr>
+              <a:t>N em 1</a:t>
+            </a:r>
+            <a:endParaRPr lang="en-US" sz="1400" dirty="0"/>
+          </a:p>
+          <a:p>
+            <a:pPr indent="0" marL="0">
+              <a:buNone/>
+            </a:pPr>
+            <a:r>
+              <a:rPr lang="en-US" sz="1400" dirty="0">
+                <a:solidFill>
+                  <a:srgbClr val="4B5563"/>
+                </a:solidFill>
+                <a:latin typeface="Montserrat" pitchFamily="34" charset="0"/>
+                <a:ea typeface="Montserrat" pitchFamily="34" charset="-122"/>
+                <a:cs typeface="Montserrat" pitchFamily="34" charset="-120"/>
+              </a:rPr>
+              <a:t>perguntas na mesma chamada: o texto é pago uma vez</a:t>
+            </a:r>
+            <a:endParaRPr lang="en-US" sz="1400" dirty="0"/>
+          </a:p>
+        </p:txBody>
+      </p:sp>
+      <p:sp>
+        <p:nvSpPr>
+          <p:cNvPr id="24" name="Text 21"/>
+          <p:cNvSpPr txBox="1"/>
+          <p:nvPr/>
+        </p:nvSpPr>
+        <p:spPr>
+          <a:xfrm>
+            <a:off x="548640" y="5833872"/>
+            <a:ext cx="11091672" cy="274320"/>
+          </a:xfrm>
+          <a:prstGeom prst="rect">
+            <a:avLst/>
+          </a:prstGeom>
+          <a:noFill/>
+          <a:ln/>
+        </p:spPr>
+        <p:txBody>
+          <a:bodyPr wrap="square" lIns="0" tIns="0" rIns="0" bIns="0" rtlCol="0" anchor="t"/>
+          <a:lstStyle/>
+          <a:p>
+            <a:pPr indent="0" marL="0">
+              <a:buNone/>
+            </a:pPr>
+            <a:r>
+              <a:rPr lang="en-US" sz="1000" dirty="0">
+                <a:solidFill>
+                  <a:srgbClr val="6B7280"/>
+                </a:solidFill>
+                <a:latin typeface="Montserrat" pitchFamily="34" charset="0"/>
+                <a:ea typeface="Montserrat" pitchFamily="34" charset="-122"/>
+                <a:cs typeface="Montserrat" pitchFamily="34" charset="-120"/>
+              </a:rPr>
+              <a:t>* Custo medido no laboratório: US$ 0,000078 por avaliação, com ~1.850 tokens de entrada e 5 perguntas. Textos maiores custam proporcionalmente mais.</a:t>
+            </a:r>
+            <a:endParaRPr lang="en-US" sz="1000" dirty="0"/>
+          </a:p>
+        </p:txBody>
+      </p:sp>
+    </p:spTree>
+  </p:cSld>
+  <p:clrMapOvr>
+    <a:masterClrMapping/>
+  </p:clrMapOvr>
+</p:sld>
+</file>
+
+<file path=ppt/slides/slide43.xml><?xml version="1.0" encoding="utf-8"?>
+<p:sld xmlns:a="http://schemas.openxmlformats.org/drawingml/2006/main" xmlns:r="http://schemas.openxmlformats.org/officeDocument/2006/relationships" xmlns:p="http://schemas.openxmlformats.org/presentationml/2006/main">
+  <p:cSld name="Slide 43">
+    <p:bg>
+      <p:bgPr>
+        <a:solidFill>
+          <a:srgbClr val="FAFAFA"/>
+        </a:solidFill>
+      </p:bgPr>
+    </p:bg>
+    <p:spTree>
+      <p:nvGrpSpPr>
+        <p:cNvPr id="1" name=""/>
+        <p:cNvGrpSpPr/>
+        <p:nvPr/>
+      </p:nvGrpSpPr>
+      <p:grpSpPr>
+        <a:xfrm>
+          <a:off x="0" y="0"/>
+          <a:ext cx="0" cy="0"/>
+          <a:chOff x="0" y="0"/>
+          <a:chExt cx="0" cy="0"/>
+        </a:xfrm>
+      </p:grpSpPr>
+      <p:sp>
+        <p:nvSpPr>
+          <p:cNvPr id="2" name="Text 0"/>
+          <p:cNvSpPr txBox="1"/>
+          <p:nvPr/>
+        </p:nvSpPr>
+        <p:spPr>
+          <a:xfrm>
+            <a:off x="548640" y="365760"/>
+            <a:ext cx="8229600" cy="274320"/>
+          </a:xfrm>
+          <a:prstGeom prst="rect">
+            <a:avLst/>
+          </a:prstGeom>
+          <a:noFill/>
+          <a:ln/>
+        </p:spPr>
+        <p:txBody>
+          <a:bodyPr wrap="square" lIns="0" tIns="0" rIns="0" bIns="0" rtlCol="0" anchor="t"/>
+          <a:lstStyle/>
+          <a:p>
+            <a:pPr indent="0" marL="0">
+              <a:buNone/>
+            </a:pPr>
+            <a:r>
+              <a:rPr lang="en-US" sz="1200" b="1" spc="200" kern="0" dirty="0">
+                <a:solidFill>
+                  <a:srgbClr val="5922A5"/>
+                </a:solidFill>
+                <a:latin typeface="Montserrat" pitchFamily="34" charset="0"/>
+                <a:ea typeface="Montserrat" pitchFamily="34" charset="-122"/>
+                <a:cs typeface="Montserrat" pitchFamily="34" charset="-120"/>
+              </a:rPr>
+              <a:t>CASOS DE USO · ONDE APLICAR AMANHÃ</a:t>
+            </a:r>
+            <a:endParaRPr lang="en-US" sz="1200" dirty="0"/>
+          </a:p>
+        </p:txBody>
+      </p:sp>
+      <p:sp>
+        <p:nvSpPr>
+          <p:cNvPr id="3" name="Text 0"/>
+          <p:cNvSpPr/>
+          <p:nvPr>
+            <p:ph idx="100" type="title" hasCustomPrompt="1"/>
+          </p:nvPr>
+        </p:nvSpPr>
+        <p:spPr>
+          <a:xfrm>
+            <a:off x="548640" y="658368"/>
+            <a:ext cx="9692640" cy="685800"/>
+          </a:xfrm>
+          <a:prstGeom prst="rect">
+            <a:avLst/>
+          </a:prstGeom>
+          <a:noFill/>
+          <a:ln/>
+        </p:spPr>
+        <p:txBody>
+          <a:bodyPr wrap="square" lIns="0" tIns="0" rIns="0" bIns="0" rtlCol="0" anchor="ctr"/>
+          <a:lstStyle/>
+          <a:p>
+            <a:pPr algn="l" indent="0" marL="0">
+              <a:buNone/>
+            </a:pPr>
+            <a:r>
+              <a:rPr lang="en-US" sz="3000" b="1" dirty="0">
+                <a:solidFill>
+                  <a:srgbClr val="0A0A0A"/>
+                </a:solidFill>
+                <a:latin typeface="Montserrat" pitchFamily="34" charset="0"/>
+                <a:ea typeface="Montserrat" pitchFamily="34" charset="-122"/>
+                <a:cs typeface="Montserrat" pitchFamily="34" charset="-120"/>
+              </a:rPr>
+              <a:t>Seis decisões que o Jev automatiza</a:t>
+            </a:r>
+            <a:endParaRPr lang="en-US" sz="3000" dirty="0"/>
+          </a:p>
+        </p:txBody>
+      </p:sp>
+      <p:pic>
+        <p:nvPicPr>
+          <p:cNvPr id="4" name="Image 0" descr="/home/claude/deck/assets/logo.png">    </p:cNvPr>
+          <p:cNvPicPr>
+            <a:picLocks noChangeAspect="1"/>
+          </p:cNvPicPr>
+          <p:nvPr/>
+        </p:nvPicPr>
+        <p:blipFill>
+          <a:blip r:embed="rId1"/>
+          <a:stretch>
+            <a:fillRect/>
+          </a:stretch>
+        </p:blipFill>
+        <p:spPr>
+          <a:xfrm>
+            <a:off x="10515600" y="384048"/>
+            <a:ext cx="1143000" cy="430306"/>
+          </a:xfrm>
+          <a:prstGeom prst="rect">
+            <a:avLst/>
+          </a:prstGeom>
+        </p:spPr>
+      </p:pic>
+      <p:sp>
+        <p:nvSpPr>
+          <p:cNvPr id="5" name="Text 2"/>
+          <p:cNvSpPr txBox="1"/>
+          <p:nvPr/>
+        </p:nvSpPr>
+        <p:spPr>
+          <a:xfrm>
+            <a:off x="548640" y="6419088"/>
+            <a:ext cx="5486400" cy="256032"/>
+          </a:xfrm>
+          <a:prstGeom prst="rect">
+            <a:avLst/>
+          </a:prstGeom>
+          <a:noFill/>
+          <a:ln/>
+        </p:spPr>
+        <p:txBody>
+          <a:bodyPr wrap="square" lIns="0" tIns="0" rIns="0" bIns="0" rtlCol="0" anchor="t"/>
+          <a:lstStyle/>
+          <a:p>
+            <a:pPr indent="0" marL="0">
+              <a:buNone/>
+            </a:pPr>
+            <a:r>
+              <a:rPr lang="en-US" sz="1000" dirty="0">
+                <a:solidFill>
+                  <a:srgbClr val="6B7280"/>
+                </a:solidFill>
+                <a:latin typeface="Montserrat" pitchFamily="34" charset="0"/>
+                <a:ea typeface="Montserrat" pitchFamily="34" charset="-122"/>
+                <a:cs typeface="Montserrat" pitchFamily="34" charset="-120"/>
+              </a:rPr>
+              <a:t>Workshop JEV · WebTech Network</a:t>
+            </a:r>
+            <a:endParaRPr lang="en-US" sz="1000" dirty="0"/>
+          </a:p>
+        </p:txBody>
+      </p:sp>
+      <p:sp>
+        <p:nvSpPr>
+          <p:cNvPr id="6" name="Text 3"/>
+          <p:cNvSpPr txBox="1"/>
+          <p:nvPr/>
+        </p:nvSpPr>
+        <p:spPr>
+          <a:xfrm>
+            <a:off x="11091672" y="6419088"/>
+            <a:ext cx="548640" cy="256032"/>
+          </a:xfrm>
+          <a:prstGeom prst="rect">
+            <a:avLst/>
+          </a:prstGeom>
+          <a:noFill/>
+          <a:ln/>
+        </p:spPr>
+        <p:txBody>
+          <a:bodyPr wrap="square" lIns="0" tIns="0" rIns="0" bIns="0" rtlCol="0" anchor="t"/>
+          <a:lstStyle/>
+          <a:p>
+            <a:pPr algn="r" indent="0" marL="0">
+              <a:buNone/>
+            </a:pPr>
+            <a:r>
+              <a:rPr lang="en-US" sz="1000" dirty="0">
+                <a:solidFill>
+                  <a:srgbClr val="6B7280"/>
+                </a:solidFill>
+                <a:latin typeface="Montserrat" pitchFamily="34" charset="0"/>
+                <a:ea typeface="Montserrat" pitchFamily="34" charset="-122"/>
+                <a:cs typeface="Montserrat" pitchFamily="34" charset="-120"/>
+              </a:rPr>
+              <a:t>43</a:t>
+            </a:r>
+            <a:endParaRPr lang="en-US" sz="1000" dirty="0"/>
+          </a:p>
+        </p:txBody>
+      </p:sp>
+      <p:sp>
+        <p:nvSpPr>
+          <p:cNvPr id="7" name="Shape 4"/>
+          <p:cNvSpPr/>
+          <p:nvPr/>
+        </p:nvSpPr>
+        <p:spPr>
+          <a:xfrm>
+            <a:off x="548640" y="1691640"/>
+            <a:ext cx="3547872" cy="2103120"/>
+          </a:xfrm>
+          <a:prstGeom prst="roundRect">
+            <a:avLst>
+              <a:gd name="adj" fmla="val 6087"/>
+            </a:avLst>
+          </a:prstGeom>
+          <a:solidFill>
+            <a:srgbClr val="FFFFFF"/>
+          </a:solidFill>
+          <a:ln w="12700">
+            <a:solidFill>
+              <a:srgbClr val="E5E7EB"/>
+            </a:solidFill>
+            <a:prstDash val="solid"/>
+          </a:ln>
+        </p:spPr>
+      </p:sp>
+      <p:sp>
+        <p:nvSpPr>
+          <p:cNvPr id="8" name="Shape 5"/>
+          <p:cNvSpPr/>
+          <p:nvPr/>
+        </p:nvSpPr>
+        <p:spPr>
+          <a:xfrm>
+            <a:off x="777240" y="1892808"/>
+            <a:ext cx="1417320" cy="310896"/>
+          </a:xfrm>
+          <a:prstGeom prst="roundRect">
+            <a:avLst>
+              <a:gd name="adj" fmla="val 50000"/>
+            </a:avLst>
+          </a:prstGeom>
+          <a:solidFill>
+            <a:srgbClr val="EBE7F5"/>
+          </a:solidFill>
+          <a:ln/>
+        </p:spPr>
+      </p:sp>
+      <p:sp>
+        <p:nvSpPr>
+          <p:cNvPr id="9" name="Text 6"/>
+          <p:cNvSpPr txBox="1"/>
+          <p:nvPr/>
+        </p:nvSpPr>
+        <p:spPr>
+          <a:xfrm>
+            <a:off x="777240" y="1892808"/>
+            <a:ext cx="1417320" cy="310896"/>
+          </a:xfrm>
+          <a:prstGeom prst="rect">
+            <a:avLst/>
+          </a:prstGeom>
+          <a:noFill/>
+          <a:ln/>
+        </p:spPr>
+        <p:txBody>
+          <a:bodyPr wrap="square" lIns="0" tIns="0" rIns="0" bIns="0" rtlCol="0" anchor="ctr"/>
+          <a:lstStyle/>
+          <a:p>
+            <a:pPr algn="ctr" indent="0" marL="0">
+              <a:buNone/>
+            </a:pPr>
+            <a:r>
+              <a:rPr lang="en-US" sz="1100" b="1" dirty="0">
+                <a:solidFill>
+                  <a:srgbClr val="5922A5"/>
+                </a:solidFill>
+                <a:latin typeface="Montserrat" pitchFamily="34" charset="0"/>
+                <a:ea typeface="Montserrat" pitchFamily="34" charset="-122"/>
+                <a:cs typeface="Montserrat" pitchFamily="34" charset="-120"/>
+              </a:rPr>
+              <a:t>Atendimento</a:t>
+            </a:r>
+            <a:endParaRPr lang="en-US" sz="1100" dirty="0"/>
+          </a:p>
+        </p:txBody>
+      </p:sp>
+      <p:sp>
+        <p:nvSpPr>
+          <p:cNvPr id="10" name="Text 7"/>
+          <p:cNvSpPr txBox="1"/>
+          <p:nvPr/>
+        </p:nvSpPr>
+        <p:spPr>
+          <a:xfrm>
+            <a:off x="2953512" y="1892808"/>
+            <a:ext cx="914400" cy="310896"/>
+          </a:xfrm>
+          <a:prstGeom prst="rect">
+            <a:avLst/>
+          </a:prstGeom>
+          <a:noFill/>
+          <a:ln/>
+        </p:spPr>
+        <p:txBody>
+          <a:bodyPr wrap="square" lIns="0" tIns="0" rIns="0" bIns="0" rtlCol="0" anchor="ctr"/>
+          <a:lstStyle/>
+          <a:p>
+            <a:pPr algn="r" indent="0" marL="0">
+              <a:buNone/>
+            </a:pPr>
+            <a:r>
+              <a:rPr lang="en-US" sz="1200" b="1" dirty="0">
+                <a:solidFill>
+                  <a:srgbClr val="5430BF"/>
+                </a:solidFill>
+                <a:latin typeface="DejaVu Sans Mono" pitchFamily="34" charset="0"/>
+                <a:ea typeface="DejaVu Sans Mono" pitchFamily="34" charset="-122"/>
+                <a:cs typeface="DejaVu Sans Mono" pitchFamily="34" charset="-120"/>
+              </a:rPr>
+              <a:t>choice</a:t>
+            </a:r>
+            <a:endParaRPr lang="en-US" sz="1200" dirty="0"/>
+          </a:p>
+        </p:txBody>
+      </p:sp>
+      <p:sp>
+        <p:nvSpPr>
+          <p:cNvPr id="11" name="Text 8"/>
+          <p:cNvSpPr txBox="1"/>
+          <p:nvPr/>
+        </p:nvSpPr>
+        <p:spPr>
+          <a:xfrm>
+            <a:off x="777240" y="2313432"/>
+            <a:ext cx="3090672" cy="365760"/>
+          </a:xfrm>
+          <a:prstGeom prst="rect">
+            <a:avLst/>
+          </a:prstGeom>
+          <a:noFill/>
+          <a:ln/>
+        </p:spPr>
+        <p:txBody>
+          <a:bodyPr wrap="square" lIns="0" tIns="0" rIns="0" bIns="0" rtlCol="0" anchor="t"/>
+          <a:lstStyle/>
+          <a:p>
+            <a:pPr indent="0" marL="0">
+              <a:buNone/>
+            </a:pPr>
+            <a:r>
+              <a:rPr lang="en-US" sz="1700" b="1" dirty="0">
+                <a:solidFill>
+                  <a:srgbClr val="0A0A0A"/>
+                </a:solidFill>
+                <a:latin typeface="Montserrat" pitchFamily="34" charset="0"/>
+                <a:ea typeface="Montserrat" pitchFamily="34" charset="-122"/>
+                <a:cs typeface="Montserrat" pitchFamily="34" charset="-120"/>
+              </a:rPr>
+              <a:t>Triagem de tickets</a:t>
+            </a:r>
+            <a:endParaRPr lang="en-US" sz="1700" dirty="0"/>
+          </a:p>
+        </p:txBody>
+      </p:sp>
+      <p:sp>
+        <p:nvSpPr>
+          <p:cNvPr id="12" name="Text 9"/>
+          <p:cNvSpPr txBox="1"/>
+          <p:nvPr/>
+        </p:nvSpPr>
+        <p:spPr>
+          <a:xfrm>
+            <a:off x="777240" y="2697480"/>
+            <a:ext cx="3090672" cy="502920"/>
+          </a:xfrm>
+          <a:prstGeom prst="rect">
+            <a:avLst/>
+          </a:prstGeom>
+          <a:noFill/>
+          <a:ln/>
+        </p:spPr>
+        <p:txBody>
+          <a:bodyPr wrap="square" lIns="0" tIns="0" rIns="0" bIns="0" rtlCol="0" anchor="t"/>
+          <a:lstStyle/>
+          <a:p>
+            <a:pPr indent="0" marL="0">
+              <a:buNone/>
+            </a:pPr>
+            <a:r>
+              <a:rPr lang="en-US" sz="1200" i="1" dirty="0">
+                <a:solidFill>
+                  <a:srgbClr val="5922A5"/>
+                </a:solidFill>
+                <a:latin typeface="Montserrat" pitchFamily="34" charset="0"/>
+                <a:ea typeface="Montserrat" pitchFamily="34" charset="-122"/>
+                <a:cs typeface="Montserrat" pitchFamily="34" charset="-120"/>
+              </a:rPr>
+              <a:t>“Qual fila: cobrança, técnico ou cancelamento?”</a:t>
+            </a:r>
+            <a:endParaRPr lang="en-US" sz="1200" dirty="0"/>
+          </a:p>
+        </p:txBody>
+      </p:sp>
+      <p:sp>
+        <p:nvSpPr>
+          <p:cNvPr id="13" name="Text 10"/>
+          <p:cNvSpPr txBox="1"/>
+          <p:nvPr/>
+        </p:nvSpPr>
+        <p:spPr>
+          <a:xfrm>
+            <a:off x="777240" y="3200400"/>
+            <a:ext cx="3090672" cy="502920"/>
+          </a:xfrm>
+          <a:prstGeom prst="rect">
+            <a:avLst/>
+          </a:prstGeom>
+          <a:noFill/>
+          <a:ln/>
+        </p:spPr>
+        <p:txBody>
+          <a:bodyPr wrap="square" lIns="0" tIns="0" rIns="0" bIns="0" rtlCol="0" anchor="t"/>
+          <a:lstStyle/>
+          <a:p>
+            <a:pPr indent="0" marL="0">
+              <a:buNone/>
+            </a:pPr>
+            <a:r>
+              <a:rPr lang="en-US" sz="1200" dirty="0">
+                <a:solidFill>
+                  <a:srgbClr val="4B5563"/>
+                </a:solidFill>
+                <a:latin typeface="Montserrat" pitchFamily="34" charset="0"/>
+                <a:ea typeface="Montserrat" pitchFamily="34" charset="-122"/>
+                <a:cs typeface="Montserrat" pitchFamily="34" charset="-120"/>
+              </a:rPr>
+              <a:t>Ticket na fila certa em meio segundo, sem regra de palavra-chave.</a:t>
+            </a:r>
+            <a:endParaRPr lang="en-US" sz="1200" dirty="0"/>
+          </a:p>
+        </p:txBody>
+      </p:sp>
+      <p:sp>
+        <p:nvSpPr>
+          <p:cNvPr id="14" name="Shape 11"/>
+          <p:cNvSpPr/>
+          <p:nvPr/>
+        </p:nvSpPr>
+        <p:spPr>
+          <a:xfrm>
+            <a:off x="4315968" y="1691640"/>
+            <a:ext cx="3547872" cy="2103120"/>
+          </a:xfrm>
+          <a:prstGeom prst="roundRect">
+            <a:avLst>
+              <a:gd name="adj" fmla="val 6087"/>
+            </a:avLst>
+          </a:prstGeom>
+          <a:solidFill>
+            <a:srgbClr val="FFFFFF"/>
+          </a:solidFill>
+          <a:ln w="12700">
+            <a:solidFill>
+              <a:srgbClr val="E5E7EB"/>
+            </a:solidFill>
+            <a:prstDash val="solid"/>
+          </a:ln>
+        </p:spPr>
+      </p:sp>
+      <p:sp>
+        <p:nvSpPr>
+          <p:cNvPr id="15" name="Shape 12"/>
+          <p:cNvSpPr/>
+          <p:nvPr/>
+        </p:nvSpPr>
+        <p:spPr>
+          <a:xfrm>
+            <a:off x="4544568" y="1892808"/>
+            <a:ext cx="1417320" cy="310896"/>
+          </a:xfrm>
+          <a:prstGeom prst="roundRect">
+            <a:avLst>
+              <a:gd name="adj" fmla="val 50000"/>
+            </a:avLst>
+          </a:prstGeom>
+          <a:solidFill>
+            <a:srgbClr val="EBE7F5"/>
+          </a:solidFill>
+          <a:ln/>
+        </p:spPr>
+      </p:sp>
+      <p:sp>
+        <p:nvSpPr>
+          <p:cNvPr id="16" name="Text 13"/>
+          <p:cNvSpPr txBox="1"/>
+          <p:nvPr/>
+        </p:nvSpPr>
+        <p:spPr>
+          <a:xfrm>
+            <a:off x="4544568" y="1892808"/>
+            <a:ext cx="1417320" cy="310896"/>
+          </a:xfrm>
+          <a:prstGeom prst="rect">
+            <a:avLst/>
+          </a:prstGeom>
+          <a:noFill/>
+          <a:ln/>
+        </p:spPr>
+        <p:txBody>
+          <a:bodyPr wrap="square" lIns="0" tIns="0" rIns="0" bIns="0" rtlCol="0" anchor="ctr"/>
+          <a:lstStyle/>
+          <a:p>
+            <a:pPr algn="ctr" indent="0" marL="0">
+              <a:buNone/>
+            </a:pPr>
+            <a:r>
+              <a:rPr lang="en-US" sz="1100" b="1" dirty="0">
+                <a:solidFill>
+                  <a:srgbClr val="5922A5"/>
+                </a:solidFill>
+                <a:latin typeface="Montserrat" pitchFamily="34" charset="0"/>
+                <a:ea typeface="Montserrat" pitchFamily="34" charset="-122"/>
+                <a:cs typeface="Montserrat" pitchFamily="34" charset="-120"/>
+              </a:rPr>
+              <a:t>Vendas</a:t>
+            </a:r>
+            <a:endParaRPr lang="en-US" sz="1100" dirty="0"/>
+          </a:p>
+        </p:txBody>
+      </p:sp>
+      <p:sp>
+        <p:nvSpPr>
+          <p:cNvPr id="17" name="Text 14"/>
+          <p:cNvSpPr txBox="1"/>
+          <p:nvPr/>
+        </p:nvSpPr>
+        <p:spPr>
+          <a:xfrm>
+            <a:off x="6720840" y="1892808"/>
+            <a:ext cx="914400" cy="310896"/>
+          </a:xfrm>
+          <a:prstGeom prst="rect">
+            <a:avLst/>
+          </a:prstGeom>
+          <a:noFill/>
+          <a:ln/>
+        </p:spPr>
+        <p:txBody>
+          <a:bodyPr wrap="square" lIns="0" tIns="0" rIns="0" bIns="0" rtlCol="0" anchor="ctr"/>
+          <a:lstStyle/>
+          <a:p>
+            <a:pPr algn="r" indent="0" marL="0">
+              <a:buNone/>
+            </a:pPr>
+            <a:r>
+              <a:rPr lang="en-US" sz="1200" b="1" dirty="0">
+                <a:solidFill>
+                  <a:srgbClr val="5430BF"/>
+                </a:solidFill>
+                <a:latin typeface="DejaVu Sans Mono" pitchFamily="34" charset="0"/>
+                <a:ea typeface="DejaVu Sans Mono" pitchFamily="34" charset="-122"/>
+                <a:cs typeface="DejaVu Sans Mono" pitchFamily="34" charset="-120"/>
+              </a:rPr>
+              <a:t>score</a:t>
+            </a:r>
+            <a:endParaRPr lang="en-US" sz="1200" dirty="0"/>
+          </a:p>
+        </p:txBody>
+      </p:sp>
+      <p:sp>
+        <p:nvSpPr>
+          <p:cNvPr id="18" name="Text 15"/>
+          <p:cNvSpPr txBox="1"/>
+          <p:nvPr/>
+        </p:nvSpPr>
+        <p:spPr>
+          <a:xfrm>
+            <a:off x="4544568" y="2313432"/>
+            <a:ext cx="3090672" cy="365760"/>
+          </a:xfrm>
+          <a:prstGeom prst="rect">
+            <a:avLst/>
+          </a:prstGeom>
+          <a:noFill/>
+          <a:ln/>
+        </p:spPr>
+        <p:txBody>
+          <a:bodyPr wrap="square" lIns="0" tIns="0" rIns="0" bIns="0" rtlCol="0" anchor="t"/>
+          <a:lstStyle/>
+          <a:p>
+            <a:pPr indent="0" marL="0">
+              <a:buNone/>
+            </a:pPr>
+            <a:r>
+              <a:rPr lang="en-US" sz="1700" b="1" dirty="0">
+                <a:solidFill>
+                  <a:srgbClr val="0A0A0A"/>
+                </a:solidFill>
+                <a:latin typeface="Montserrat" pitchFamily="34" charset="0"/>
+                <a:ea typeface="Montserrat" pitchFamily="34" charset="-122"/>
+                <a:cs typeface="Montserrat" pitchFamily="34" charset="-120"/>
+              </a:rPr>
+              <a:t>Qualificação de leads</a:t>
+            </a:r>
+            <a:endParaRPr lang="en-US" sz="1700" dirty="0"/>
+          </a:p>
+        </p:txBody>
+      </p:sp>
+      <p:sp>
+        <p:nvSpPr>
+          <p:cNvPr id="19" name="Text 16"/>
+          <p:cNvSpPr txBox="1"/>
+          <p:nvPr/>
+        </p:nvSpPr>
+        <p:spPr>
+          <a:xfrm>
+            <a:off x="4544568" y="2697480"/>
+            <a:ext cx="3090672" cy="502920"/>
+          </a:xfrm>
+          <a:prstGeom prst="rect">
+            <a:avLst/>
+          </a:prstGeom>
+          <a:noFill/>
+          <a:ln/>
+        </p:spPr>
+        <p:txBody>
+          <a:bodyPr wrap="square" lIns="0" tIns="0" rIns="0" bIns="0" rtlCol="0" anchor="t"/>
+          <a:lstStyle/>
+          <a:p>
+            <a:pPr indent="0" marL="0">
+              <a:buNone/>
+            </a:pPr>
+            <a:r>
+              <a:rPr lang="en-US" sz="1200" i="1" dirty="0">
+                <a:solidFill>
+                  <a:srgbClr val="5922A5"/>
+                </a:solidFill>
+                <a:latin typeface="Montserrat" pitchFamily="34" charset="0"/>
+                <a:ea typeface="Montserrat" pitchFamily="34" charset="-122"/>
+                <a:cs typeface="Montserrat" pitchFamily="34" charset="-120"/>
+              </a:rPr>
+              <a:t>“Qual a intenção de compra, de 0 a 5?”</a:t>
+            </a:r>
+            <a:endParaRPr lang="en-US" sz="1200" dirty="0"/>
+          </a:p>
+        </p:txBody>
+      </p:sp>
+      <p:sp>
+        <p:nvSpPr>
+          <p:cNvPr id="20" name="Text 17"/>
+          <p:cNvSpPr txBox="1"/>
+          <p:nvPr/>
+        </p:nvSpPr>
+        <p:spPr>
+          <a:xfrm>
+            <a:off x="4544568" y="3200400"/>
+            <a:ext cx="3090672" cy="502920"/>
+          </a:xfrm>
+          <a:prstGeom prst="rect">
+            <a:avLst/>
+          </a:prstGeom>
+          <a:noFill/>
+          <a:ln/>
+        </p:spPr>
+        <p:txBody>
+          <a:bodyPr wrap="square" lIns="0" tIns="0" rIns="0" bIns="0" rtlCol="0" anchor="t"/>
+          <a:lstStyle/>
+          <a:p>
+            <a:pPr indent="0" marL="0">
+              <a:buNone/>
+            </a:pPr>
+            <a:r>
+              <a:rPr lang="en-US" sz="1200" dirty="0">
+                <a:solidFill>
+                  <a:srgbClr val="4B5563"/>
+                </a:solidFill>
+                <a:latin typeface="Montserrat" pitchFamily="34" charset="0"/>
+                <a:ea typeface="Montserrat" pitchFamily="34" charset="-122"/>
+                <a:cs typeface="Montserrat" pitchFamily="34" charset="-120"/>
+              </a:rPr>
+              <a:t>O time comercial liga primeiro para quem vai comprar.</a:t>
+            </a:r>
+            <a:endParaRPr lang="en-US" sz="1200" dirty="0"/>
+          </a:p>
+        </p:txBody>
+      </p:sp>
+      <p:sp>
+        <p:nvSpPr>
+          <p:cNvPr id="21" name="Shape 18"/>
+          <p:cNvSpPr/>
+          <p:nvPr/>
+        </p:nvSpPr>
+        <p:spPr>
+          <a:xfrm>
+            <a:off x="8083296" y="1691640"/>
+            <a:ext cx="3547872" cy="2103120"/>
+          </a:xfrm>
+          <a:prstGeom prst="roundRect">
+            <a:avLst>
+              <a:gd name="adj" fmla="val 6087"/>
+            </a:avLst>
+          </a:prstGeom>
+          <a:solidFill>
+            <a:srgbClr val="FFFFFF"/>
+          </a:solidFill>
+          <a:ln w="12700">
+            <a:solidFill>
+              <a:srgbClr val="E5E7EB"/>
+            </a:solidFill>
+            <a:prstDash val="solid"/>
+          </a:ln>
+        </p:spPr>
+      </p:sp>
+      <p:sp>
+        <p:nvSpPr>
+          <p:cNvPr id="22" name="Shape 19"/>
+          <p:cNvSpPr/>
+          <p:nvPr/>
+        </p:nvSpPr>
+        <p:spPr>
+          <a:xfrm>
+            <a:off x="8311896" y="1892808"/>
+            <a:ext cx="1417320" cy="310896"/>
+          </a:xfrm>
+          <a:prstGeom prst="roundRect">
+            <a:avLst>
+              <a:gd name="adj" fmla="val 50000"/>
+            </a:avLst>
+          </a:prstGeom>
+          <a:solidFill>
+            <a:srgbClr val="EBE7F5"/>
+          </a:solidFill>
+          <a:ln/>
+        </p:spPr>
+      </p:sp>
+      <p:sp>
+        <p:nvSpPr>
+          <p:cNvPr id="23" name="Text 20"/>
+          <p:cNvSpPr txBox="1"/>
+          <p:nvPr/>
+        </p:nvSpPr>
+        <p:spPr>
+          <a:xfrm>
+            <a:off x="8311896" y="1892808"/>
+            <a:ext cx="1417320" cy="310896"/>
+          </a:xfrm>
+          <a:prstGeom prst="rect">
+            <a:avLst/>
+          </a:prstGeom>
+          <a:noFill/>
+          <a:ln/>
+        </p:spPr>
+        <p:txBody>
+          <a:bodyPr wrap="square" lIns="0" tIns="0" rIns="0" bIns="0" rtlCol="0" anchor="ctr"/>
+          <a:lstStyle/>
+          <a:p>
+            <a:pPr algn="ctr" indent="0" marL="0">
+              <a:buNone/>
+            </a:pPr>
+            <a:r>
+              <a:rPr lang="en-US" sz="1100" b="1" dirty="0">
+                <a:solidFill>
+                  <a:srgbClr val="5922A5"/>
+                </a:solidFill>
+                <a:latin typeface="Montserrat" pitchFamily="34" charset="0"/>
+                <a:ea typeface="Montserrat" pitchFamily="34" charset="-122"/>
+                <a:cs typeface="Montserrat" pitchFamily="34" charset="-120"/>
+              </a:rPr>
+              <a:t>Jurídico</a:t>
+            </a:r>
+            <a:endParaRPr lang="en-US" sz="1100" dirty="0"/>
+          </a:p>
+        </p:txBody>
+      </p:sp>
+      <p:sp>
+        <p:nvSpPr>
+          <p:cNvPr id="24" name="Text 21"/>
+          <p:cNvSpPr txBox="1"/>
+          <p:nvPr/>
+        </p:nvSpPr>
+        <p:spPr>
+          <a:xfrm>
+            <a:off x="10488168" y="1892808"/>
+            <a:ext cx="914400" cy="310896"/>
+          </a:xfrm>
+          <a:prstGeom prst="rect">
+            <a:avLst/>
+          </a:prstGeom>
+          <a:noFill/>
+          <a:ln/>
+        </p:spPr>
+        <p:txBody>
+          <a:bodyPr wrap="square" lIns="0" tIns="0" rIns="0" bIns="0" rtlCol="0" anchor="ctr"/>
+          <a:lstStyle/>
+          <a:p>
+            <a:pPr algn="r" indent="0" marL="0">
+              <a:buNone/>
+            </a:pPr>
+            <a:r>
+              <a:rPr lang="en-US" sz="1200" b="1" dirty="0">
+                <a:solidFill>
+                  <a:srgbClr val="5430BF"/>
+                </a:solidFill>
+                <a:latin typeface="DejaVu Sans Mono" pitchFamily="34" charset="0"/>
+                <a:ea typeface="DejaVu Sans Mono" pitchFamily="34" charset="-122"/>
+                <a:cs typeface="DejaVu Sans Mono" pitchFamily="34" charset="-120"/>
+              </a:rPr>
+              <a:t>boolean</a:t>
+            </a:r>
+            <a:endParaRPr lang="en-US" sz="1200" dirty="0"/>
+          </a:p>
+        </p:txBody>
+      </p:sp>
+      <p:sp>
+        <p:nvSpPr>
+          <p:cNvPr id="25" name="Text 22"/>
+          <p:cNvSpPr txBox="1"/>
+          <p:nvPr/>
+        </p:nvSpPr>
+        <p:spPr>
+          <a:xfrm>
+            <a:off x="8311896" y="2313432"/>
+            <a:ext cx="3090672" cy="365760"/>
+          </a:xfrm>
+          <a:prstGeom prst="rect">
+            <a:avLst/>
+          </a:prstGeom>
+          <a:noFill/>
+          <a:ln/>
+        </p:spPr>
+        <p:txBody>
+          <a:bodyPr wrap="square" lIns="0" tIns="0" rIns="0" bIns="0" rtlCol="0" anchor="t"/>
+          <a:lstStyle/>
+          <a:p>
+            <a:pPr indent="0" marL="0">
+              <a:buNone/>
+            </a:pPr>
+            <a:r>
+              <a:rPr lang="en-US" sz="1700" b="1" dirty="0">
+                <a:solidFill>
+                  <a:srgbClr val="0A0A0A"/>
+                </a:solidFill>
+                <a:latin typeface="Montserrat" pitchFamily="34" charset="0"/>
+                <a:ea typeface="Montserrat" pitchFamily="34" charset="-122"/>
+                <a:cs typeface="Montserrat" pitchFamily="34" charset="-120"/>
+              </a:rPr>
+              <a:t>Revisão de contratos</a:t>
+            </a:r>
+            <a:endParaRPr lang="en-US" sz="1700" dirty="0"/>
+          </a:p>
+        </p:txBody>
+      </p:sp>
+      <p:sp>
+        <p:nvSpPr>
+          <p:cNvPr id="26" name="Text 23"/>
+          <p:cNvSpPr txBox="1"/>
+          <p:nvPr/>
+        </p:nvSpPr>
+        <p:spPr>
+          <a:xfrm>
+            <a:off x="8311896" y="2697480"/>
+            <a:ext cx="3090672" cy="502920"/>
+          </a:xfrm>
+          <a:prstGeom prst="rect">
+            <a:avLst/>
+          </a:prstGeom>
+          <a:noFill/>
+          <a:ln/>
+        </p:spPr>
+        <p:txBody>
+          <a:bodyPr wrap="square" lIns="0" tIns="0" rIns="0" bIns="0" rtlCol="0" anchor="t"/>
+          <a:lstStyle/>
+          <a:p>
+            <a:pPr indent="0" marL="0">
+              <a:buNone/>
+            </a:pPr>
+            <a:r>
+              <a:rPr lang="en-US" sz="1200" i="1" dirty="0">
+                <a:solidFill>
+                  <a:srgbClr val="5922A5"/>
+                </a:solidFill>
+                <a:latin typeface="Montserrat" pitchFamily="34" charset="0"/>
+                <a:ea typeface="Montserrat" pitchFamily="34" charset="-122"/>
+                <a:cs typeface="Montserrat" pitchFamily="34" charset="-120"/>
+              </a:rPr>
+              <a:t>“Há multa rescisória fora do padrão da empresa?”</a:t>
+            </a:r>
+            <a:endParaRPr lang="en-US" sz="1200" dirty="0"/>
+          </a:p>
+        </p:txBody>
+      </p:sp>
+      <p:sp>
+        <p:nvSpPr>
+          <p:cNvPr id="27" name="Text 24"/>
+          <p:cNvSpPr txBox="1"/>
+          <p:nvPr/>
+        </p:nvSpPr>
+        <p:spPr>
+          <a:xfrm>
+            <a:off x="8311896" y="3200400"/>
+            <a:ext cx="3090672" cy="502920"/>
+          </a:xfrm>
+          <a:prstGeom prst="rect">
+            <a:avLst/>
+          </a:prstGeom>
+          <a:noFill/>
+          <a:ln/>
+        </p:spPr>
+        <p:txBody>
+          <a:bodyPr wrap="square" lIns="0" tIns="0" rIns="0" bIns="0" rtlCol="0" anchor="t"/>
+          <a:lstStyle/>
+          <a:p>
+            <a:pPr indent="0" marL="0">
+              <a:buNone/>
+            </a:pPr>
+            <a:r>
+              <a:rPr lang="en-US" sz="1200" dirty="0">
+                <a:solidFill>
+                  <a:srgbClr val="4B5563"/>
+                </a:solidFill>
+                <a:latin typeface="Montserrat" pitchFamily="34" charset="0"/>
+                <a:ea typeface="Montserrat" pitchFamily="34" charset="-122"/>
+                <a:cs typeface="Montserrat" pitchFamily="34" charset="-120"/>
+              </a:rPr>
+              <a:t>O advogado só lê o que foi sinalizado.</a:t>
+            </a:r>
+            <a:endParaRPr lang="en-US" sz="1200" dirty="0"/>
+          </a:p>
+        </p:txBody>
+      </p:sp>
+      <p:sp>
+        <p:nvSpPr>
+          <p:cNvPr id="28" name="Shape 25"/>
+          <p:cNvSpPr/>
+          <p:nvPr/>
+        </p:nvSpPr>
+        <p:spPr>
+          <a:xfrm>
+            <a:off x="548640" y="3931920"/>
+            <a:ext cx="3547872" cy="2103120"/>
+          </a:xfrm>
+          <a:prstGeom prst="roundRect">
+            <a:avLst>
+              <a:gd name="adj" fmla="val 6087"/>
+            </a:avLst>
+          </a:prstGeom>
+          <a:solidFill>
+            <a:srgbClr val="5922A5"/>
+          </a:solidFill>
+          <a:ln w="12700">
+            <a:solidFill>
+              <a:srgbClr val="5922A5"/>
+            </a:solidFill>
+            <a:prstDash val="solid"/>
+          </a:ln>
+        </p:spPr>
+      </p:sp>
+      <p:sp>
+        <p:nvSpPr>
+          <p:cNvPr id="29" name="Shape 26"/>
+          <p:cNvSpPr/>
+          <p:nvPr/>
+        </p:nvSpPr>
+        <p:spPr>
+          <a:xfrm>
+            <a:off x="777240" y="4133088"/>
+            <a:ext cx="1417320" cy="310896"/>
+          </a:xfrm>
+          <a:prstGeom prst="roundRect">
+            <a:avLst>
+              <a:gd name="adj" fmla="val 50000"/>
+            </a:avLst>
+          </a:prstGeom>
+          <a:solidFill>
+            <a:srgbClr val="FFC31A"/>
+          </a:solidFill>
+          <a:ln/>
+        </p:spPr>
+      </p:sp>
+      <p:sp>
+        <p:nvSpPr>
+          <p:cNvPr id="30" name="Text 27"/>
+          <p:cNvSpPr txBox="1"/>
+          <p:nvPr/>
+        </p:nvSpPr>
+        <p:spPr>
+          <a:xfrm>
+            <a:off x="777240" y="4133088"/>
+            <a:ext cx="1417320" cy="310896"/>
+          </a:xfrm>
+          <a:prstGeom prst="rect">
+            <a:avLst/>
+          </a:prstGeom>
+          <a:noFill/>
+          <a:ln/>
+        </p:spPr>
+        <p:txBody>
+          <a:bodyPr wrap="square" lIns="0" tIns="0" rIns="0" bIns="0" rtlCol="0" anchor="ctr"/>
+          <a:lstStyle/>
+          <a:p>
+            <a:pPr algn="ctr" indent="0" marL="0">
+              <a:buNone/>
+            </a:pPr>
+            <a:r>
+              <a:rPr lang="en-US" sz="1100" b="1" dirty="0">
+                <a:solidFill>
+                  <a:srgbClr val="0A0A0A"/>
+                </a:solidFill>
+                <a:latin typeface="Montserrat" pitchFamily="34" charset="0"/>
+                <a:ea typeface="Montserrat" pitchFamily="34" charset="-122"/>
+                <a:cs typeface="Montserrat" pitchFamily="34" charset="-120"/>
+              </a:rPr>
+              <a:t>IA generativa</a:t>
+            </a:r>
+            <a:endParaRPr lang="en-US" sz="1100" dirty="0"/>
+          </a:p>
+        </p:txBody>
+      </p:sp>
+      <p:sp>
+        <p:nvSpPr>
+          <p:cNvPr id="31" name="Text 28"/>
+          <p:cNvSpPr txBox="1"/>
+          <p:nvPr/>
+        </p:nvSpPr>
+        <p:spPr>
+          <a:xfrm>
+            <a:off x="2953512" y="4133088"/>
+            <a:ext cx="914400" cy="310896"/>
+          </a:xfrm>
+          <a:prstGeom prst="rect">
+            <a:avLst/>
+          </a:prstGeom>
+          <a:noFill/>
+          <a:ln/>
+        </p:spPr>
+        <p:txBody>
+          <a:bodyPr wrap="square" lIns="0" tIns="0" rIns="0" bIns="0" rtlCol="0" anchor="ctr"/>
+          <a:lstStyle/>
+          <a:p>
+            <a:pPr algn="r" indent="0" marL="0">
+              <a:buNone/>
+            </a:pPr>
+            <a:r>
+              <a:rPr lang="en-US" sz="1200" b="1" dirty="0">
+                <a:solidFill>
+                  <a:srgbClr val="FFC31A"/>
+                </a:solidFill>
+                <a:latin typeface="DejaVu Sans Mono" pitchFamily="34" charset="0"/>
+                <a:ea typeface="DejaVu Sans Mono" pitchFamily="34" charset="-122"/>
+                <a:cs typeface="DejaVu Sans Mono" pitchFamily="34" charset="-120"/>
+              </a:rPr>
+              <a:t>score</a:t>
+            </a:r>
+            <a:endParaRPr lang="en-US" sz="1200" dirty="0"/>
+          </a:p>
+        </p:txBody>
+      </p:sp>
+      <p:sp>
+        <p:nvSpPr>
+          <p:cNvPr id="32" name="Text 29"/>
+          <p:cNvSpPr txBox="1"/>
+          <p:nvPr/>
+        </p:nvSpPr>
+        <p:spPr>
+          <a:xfrm>
+            <a:off x="777240" y="4553712"/>
+            <a:ext cx="3090672" cy="365760"/>
+          </a:xfrm>
+          <a:prstGeom prst="rect">
+            <a:avLst/>
+          </a:prstGeom>
+          <a:noFill/>
+          <a:ln/>
+        </p:spPr>
+        <p:txBody>
+          <a:bodyPr wrap="square" lIns="0" tIns="0" rIns="0" bIns="0" rtlCol="0" anchor="t"/>
+          <a:lstStyle/>
+          <a:p>
+            <a:pPr indent="0" marL="0">
+              <a:buNone/>
+            </a:pPr>
+            <a:r>
+              <a:rPr lang="en-US" sz="1700" b="1" dirty="0">
+                <a:solidFill>
+                  <a:srgbClr val="FFFFFF"/>
+                </a:solidFill>
+                <a:latin typeface="Montserrat" pitchFamily="34" charset="0"/>
+                <a:ea typeface="Montserrat" pitchFamily="34" charset="-122"/>
+                <a:cs typeface="Montserrat" pitchFamily="34" charset="-120"/>
+              </a:rPr>
+              <a:t>Guardrail de LLM</a:t>
+            </a:r>
+            <a:endParaRPr lang="en-US" sz="1700" dirty="0"/>
+          </a:p>
+        </p:txBody>
+      </p:sp>
+      <p:sp>
+        <p:nvSpPr>
+          <p:cNvPr id="33" name="Text 30"/>
+          <p:cNvSpPr txBox="1"/>
+          <p:nvPr/>
+        </p:nvSpPr>
+        <p:spPr>
+          <a:xfrm>
+            <a:off x="777240" y="4937760"/>
+            <a:ext cx="3090672" cy="502920"/>
+          </a:xfrm>
+          <a:prstGeom prst="rect">
+            <a:avLst/>
+          </a:prstGeom>
+          <a:noFill/>
+          <a:ln/>
+        </p:spPr>
+        <p:txBody>
+          <a:bodyPr wrap="square" lIns="0" tIns="0" rIns="0" bIns="0" rtlCol="0" anchor="t"/>
+          <a:lstStyle/>
+          <a:p>
+            <a:pPr indent="0" marL="0">
+              <a:buNone/>
+            </a:pPr>
+            <a:r>
+              <a:rPr lang="en-US" sz="1200" i="1" dirty="0">
+                <a:solidFill>
+                  <a:srgbClr val="E4DAF7"/>
+                </a:solidFill>
+                <a:latin typeface="Montserrat" pitchFamily="34" charset="0"/>
+                <a:ea typeface="Montserrat" pitchFamily="34" charset="-122"/>
+                <a:cs typeface="Montserrat" pitchFamily="34" charset="-120"/>
+              </a:rPr>
+              <a:t>“A resposta do agente está apoiada no documento?”</a:t>
+            </a:r>
+            <a:endParaRPr lang="en-US" sz="1200" dirty="0"/>
+          </a:p>
+        </p:txBody>
+      </p:sp>
+      <p:sp>
+        <p:nvSpPr>
+          <p:cNvPr id="34" name="Text 31"/>
+          <p:cNvSpPr txBox="1"/>
+          <p:nvPr/>
+        </p:nvSpPr>
+        <p:spPr>
+          <a:xfrm>
+            <a:off x="777240" y="5440680"/>
+            <a:ext cx="3090672" cy="502920"/>
+          </a:xfrm>
+          <a:prstGeom prst="rect">
+            <a:avLst/>
+          </a:prstGeom>
+          <a:noFill/>
+          <a:ln/>
+        </p:spPr>
+        <p:txBody>
+          <a:bodyPr wrap="square" lIns="0" tIns="0" rIns="0" bIns="0" rtlCol="0" anchor="t"/>
+          <a:lstStyle/>
+          <a:p>
+            <a:pPr indent="0" marL="0">
+              <a:buNone/>
+            </a:pPr>
+            <a:r>
+              <a:rPr lang="en-US" sz="1200" dirty="0">
+                <a:solidFill>
+                  <a:srgbClr val="FFFFFF"/>
+                </a:solidFill>
+                <a:latin typeface="Montserrat" pitchFamily="34" charset="0"/>
+                <a:ea typeface="Montserrat" pitchFamily="34" charset="-122"/>
+                <a:cs typeface="Montserrat" pitchFamily="34" charset="-120"/>
+              </a:rPr>
+              <a:t>Barra a alucinação antes de ela chegar no cliente.</a:t>
+            </a:r>
+            <a:endParaRPr lang="en-US" sz="1200" dirty="0"/>
+          </a:p>
+        </p:txBody>
+      </p:sp>
+      <p:sp>
+        <p:nvSpPr>
+          <p:cNvPr id="35" name="Shape 32"/>
+          <p:cNvSpPr/>
+          <p:nvPr/>
+        </p:nvSpPr>
+        <p:spPr>
+          <a:xfrm>
+            <a:off x="4315968" y="3931920"/>
+            <a:ext cx="3547872" cy="2103120"/>
+          </a:xfrm>
+          <a:prstGeom prst="roundRect">
+            <a:avLst>
+              <a:gd name="adj" fmla="val 6087"/>
+            </a:avLst>
+          </a:prstGeom>
+          <a:solidFill>
+            <a:srgbClr val="FFFFFF"/>
+          </a:solidFill>
+          <a:ln w="12700">
+            <a:solidFill>
+              <a:srgbClr val="E5E7EB"/>
+            </a:solidFill>
+            <a:prstDash val="solid"/>
+          </a:ln>
+        </p:spPr>
+      </p:sp>
+      <p:sp>
+        <p:nvSpPr>
+          <p:cNvPr id="36" name="Shape 33"/>
+          <p:cNvSpPr/>
+          <p:nvPr/>
+        </p:nvSpPr>
+        <p:spPr>
+          <a:xfrm>
+            <a:off x="4544568" y="4133088"/>
+            <a:ext cx="1417320" cy="310896"/>
+          </a:xfrm>
+          <a:prstGeom prst="roundRect">
+            <a:avLst>
+              <a:gd name="adj" fmla="val 50000"/>
+            </a:avLst>
+          </a:prstGeom>
+          <a:solidFill>
+            <a:srgbClr val="EBE7F5"/>
+          </a:solidFill>
+          <a:ln/>
+        </p:spPr>
+      </p:sp>
+      <p:sp>
+        <p:nvSpPr>
+          <p:cNvPr id="37" name="Text 34"/>
+          <p:cNvSpPr txBox="1"/>
+          <p:nvPr/>
+        </p:nvSpPr>
+        <p:spPr>
+          <a:xfrm>
+            <a:off x="4544568" y="4133088"/>
+            <a:ext cx="1417320" cy="310896"/>
+          </a:xfrm>
+          <a:prstGeom prst="rect">
+            <a:avLst/>
+          </a:prstGeom>
+          <a:noFill/>
+          <a:ln/>
+        </p:spPr>
+        <p:txBody>
+          <a:bodyPr wrap="square" lIns="0" tIns="0" rIns="0" bIns="0" rtlCol="0" anchor="ctr"/>
+          <a:lstStyle/>
+          <a:p>
+            <a:pPr algn="ctr" indent="0" marL="0">
+              <a:buNone/>
+            </a:pPr>
+            <a:r>
+              <a:rPr lang="en-US" sz="1100" b="1" dirty="0">
+                <a:solidFill>
+                  <a:srgbClr val="5922A5"/>
+                </a:solidFill>
+                <a:latin typeface="Montserrat" pitchFamily="34" charset="0"/>
+                <a:ea typeface="Montserrat" pitchFamily="34" charset="-122"/>
+                <a:cs typeface="Montserrat" pitchFamily="34" charset="-120"/>
+              </a:rPr>
+              <a:t>Risco</a:t>
+            </a:r>
+            <a:endParaRPr lang="en-US" sz="1100" dirty="0"/>
+          </a:p>
+        </p:txBody>
+      </p:sp>
+      <p:sp>
+        <p:nvSpPr>
+          <p:cNvPr id="38" name="Text 35"/>
+          <p:cNvSpPr txBox="1"/>
+          <p:nvPr/>
+        </p:nvSpPr>
+        <p:spPr>
+          <a:xfrm>
+            <a:off x="6720840" y="4133088"/>
+            <a:ext cx="914400" cy="310896"/>
+          </a:xfrm>
+          <a:prstGeom prst="rect">
+            <a:avLst/>
+          </a:prstGeom>
+          <a:noFill/>
+          <a:ln/>
+        </p:spPr>
+        <p:txBody>
+          <a:bodyPr wrap="square" lIns="0" tIns="0" rIns="0" bIns="0" rtlCol="0" anchor="ctr"/>
+          <a:lstStyle/>
+          <a:p>
+            <a:pPr algn="r" indent="0" marL="0">
+              <a:buNone/>
+            </a:pPr>
+            <a:r>
+              <a:rPr lang="en-US" sz="1200" b="1" dirty="0">
+                <a:solidFill>
+                  <a:srgbClr val="5430BF"/>
+                </a:solidFill>
+                <a:latin typeface="DejaVu Sans Mono" pitchFamily="34" charset="0"/>
+                <a:ea typeface="DejaVu Sans Mono" pitchFamily="34" charset="-122"/>
+                <a:cs typeface="DejaVu Sans Mono" pitchFamily="34" charset="-120"/>
+              </a:rPr>
+              <a:t>boolean</a:t>
+            </a:r>
+            <a:endParaRPr lang="en-US" sz="1200" dirty="0"/>
+          </a:p>
+        </p:txBody>
+      </p:sp>
+      <p:sp>
+        <p:nvSpPr>
+          <p:cNvPr id="39" name="Text 36"/>
+          <p:cNvSpPr txBox="1"/>
+          <p:nvPr/>
+        </p:nvSpPr>
+        <p:spPr>
+          <a:xfrm>
+            <a:off x="4544568" y="4553712"/>
+            <a:ext cx="3090672" cy="365760"/>
+          </a:xfrm>
+          <a:prstGeom prst="rect">
+            <a:avLst/>
+          </a:prstGeom>
+          <a:noFill/>
+          <a:ln/>
+        </p:spPr>
+        <p:txBody>
+          <a:bodyPr wrap="square" lIns="0" tIns="0" rIns="0" bIns="0" rtlCol="0" anchor="t"/>
+          <a:lstStyle/>
+          <a:p>
+            <a:pPr indent="0" marL="0">
+              <a:buNone/>
+            </a:pPr>
+            <a:r>
+              <a:rPr lang="en-US" sz="1700" b="1" dirty="0">
+                <a:solidFill>
+                  <a:srgbClr val="0A0A0A"/>
+                </a:solidFill>
+                <a:latin typeface="Montserrat" pitchFamily="34" charset="0"/>
+                <a:ea typeface="Montserrat" pitchFamily="34" charset="-122"/>
+                <a:cs typeface="Montserrat" pitchFamily="34" charset="-120"/>
+              </a:rPr>
+              <a:t>Sinais de fraude</a:t>
+            </a:r>
+            <a:endParaRPr lang="en-US" sz="1700" dirty="0"/>
+          </a:p>
+        </p:txBody>
+      </p:sp>
+      <p:sp>
+        <p:nvSpPr>
+          <p:cNvPr id="40" name="Text 37"/>
+          <p:cNvSpPr txBox="1"/>
+          <p:nvPr/>
+        </p:nvSpPr>
+        <p:spPr>
+          <a:xfrm>
+            <a:off x="4544568" y="4937760"/>
+            <a:ext cx="3090672" cy="502920"/>
+          </a:xfrm>
+          <a:prstGeom prst="rect">
+            <a:avLst/>
+          </a:prstGeom>
+          <a:noFill/>
+          <a:ln/>
+        </p:spPr>
+        <p:txBody>
+          <a:bodyPr wrap="square" lIns="0" tIns="0" rIns="0" bIns="0" rtlCol="0" anchor="t"/>
+          <a:lstStyle/>
+          <a:p>
+            <a:pPr indent="0" marL="0">
+              <a:buNone/>
+            </a:pPr>
+            <a:r>
+              <a:rPr lang="en-US" sz="1200" i="1" dirty="0">
+                <a:solidFill>
+                  <a:srgbClr val="5922A5"/>
+                </a:solidFill>
+                <a:latin typeface="Montserrat" pitchFamily="34" charset="0"/>
+                <a:ea typeface="Montserrat" pitchFamily="34" charset="-122"/>
+                <a:cs typeface="Montserrat" pitchFamily="34" charset="-120"/>
+              </a:rPr>
+              <a:t>“A mensagem pede pagamento fora do canal oficial?”</a:t>
+            </a:r>
+            <a:endParaRPr lang="en-US" sz="1200" dirty="0"/>
+          </a:p>
+        </p:txBody>
+      </p:sp>
+      <p:sp>
+        <p:nvSpPr>
+          <p:cNvPr id="41" name="Text 38"/>
+          <p:cNvSpPr txBox="1"/>
+          <p:nvPr/>
+        </p:nvSpPr>
+        <p:spPr>
+          <a:xfrm>
+            <a:off x="4544568" y="5440680"/>
+            <a:ext cx="3090672" cy="502920"/>
+          </a:xfrm>
+          <a:prstGeom prst="rect">
+            <a:avLst/>
+          </a:prstGeom>
+          <a:noFill/>
+          <a:ln/>
+        </p:spPr>
+        <p:txBody>
+          <a:bodyPr wrap="square" lIns="0" tIns="0" rIns="0" bIns="0" rtlCol="0" anchor="t"/>
+          <a:lstStyle/>
+          <a:p>
+            <a:pPr indent="0" marL="0">
+              <a:buNone/>
+            </a:pPr>
+            <a:r>
+              <a:rPr lang="en-US" sz="1200" dirty="0">
+                <a:solidFill>
+                  <a:srgbClr val="4B5563"/>
+                </a:solidFill>
+                <a:latin typeface="Montserrat" pitchFamily="34" charset="0"/>
+                <a:ea typeface="Montserrat" pitchFamily="34" charset="-122"/>
+                <a:cs typeface="Montserrat" pitchFamily="34" charset="-120"/>
+              </a:rPr>
+              <a:t>Bloqueia o golpe no primeiro contato, em escala.</a:t>
+            </a:r>
+            <a:endParaRPr lang="en-US" sz="1200" dirty="0"/>
+          </a:p>
+        </p:txBody>
+      </p:sp>
+      <p:sp>
+        <p:nvSpPr>
+          <p:cNvPr id="42" name="Shape 39"/>
+          <p:cNvSpPr/>
+          <p:nvPr/>
+        </p:nvSpPr>
+        <p:spPr>
+          <a:xfrm>
+            <a:off x="8083296" y="3931920"/>
+            <a:ext cx="3547872" cy="2103120"/>
+          </a:xfrm>
+          <a:prstGeom prst="roundRect">
+            <a:avLst>
+              <a:gd name="adj" fmla="val 6087"/>
+            </a:avLst>
+          </a:prstGeom>
+          <a:solidFill>
+            <a:srgbClr val="FFFFFF"/>
+          </a:solidFill>
+          <a:ln w="12700">
+            <a:solidFill>
+              <a:srgbClr val="E5E7EB"/>
+            </a:solidFill>
+            <a:prstDash val="solid"/>
+          </a:ln>
+        </p:spPr>
+      </p:sp>
+      <p:sp>
+        <p:nvSpPr>
+          <p:cNvPr id="43" name="Shape 40"/>
+          <p:cNvSpPr/>
+          <p:nvPr/>
+        </p:nvSpPr>
+        <p:spPr>
+          <a:xfrm>
+            <a:off x="8311896" y="4133088"/>
+            <a:ext cx="1417320" cy="310896"/>
+          </a:xfrm>
+          <a:prstGeom prst="roundRect">
+            <a:avLst>
+              <a:gd name="adj" fmla="val 50000"/>
+            </a:avLst>
+          </a:prstGeom>
+          <a:solidFill>
+            <a:srgbClr val="EBE7F5"/>
+          </a:solidFill>
+          <a:ln/>
+        </p:spPr>
+      </p:sp>
+      <p:sp>
+        <p:nvSpPr>
+          <p:cNvPr id="44" name="Text 41"/>
+          <p:cNvSpPr txBox="1"/>
+          <p:nvPr/>
+        </p:nvSpPr>
+        <p:spPr>
+          <a:xfrm>
+            <a:off x="8311896" y="4133088"/>
+            <a:ext cx="1417320" cy="310896"/>
+          </a:xfrm>
+          <a:prstGeom prst="rect">
+            <a:avLst/>
+          </a:prstGeom>
+          <a:noFill/>
+          <a:ln/>
+        </p:spPr>
+        <p:txBody>
+          <a:bodyPr wrap="square" lIns="0" tIns="0" rIns="0" bIns="0" rtlCol="0" anchor="ctr"/>
+          <a:lstStyle/>
+          <a:p>
+            <a:pPr algn="ctr" indent="0" marL="0">
+              <a:buNone/>
+            </a:pPr>
+            <a:r>
+              <a:rPr lang="en-US" sz="1100" b="1" dirty="0">
+                <a:solidFill>
+                  <a:srgbClr val="5922A5"/>
+                </a:solidFill>
+                <a:latin typeface="Montserrat" pitchFamily="34" charset="0"/>
+                <a:ea typeface="Montserrat" pitchFamily="34" charset="-122"/>
+                <a:cs typeface="Montserrat" pitchFamily="34" charset="-120"/>
+              </a:rPr>
+              <a:t>Qualidade</a:t>
+            </a:r>
+            <a:endParaRPr lang="en-US" sz="1100" dirty="0"/>
+          </a:p>
+        </p:txBody>
+      </p:sp>
+      <p:sp>
+        <p:nvSpPr>
+          <p:cNvPr id="45" name="Text 42"/>
+          <p:cNvSpPr txBox="1"/>
+          <p:nvPr/>
+        </p:nvSpPr>
+        <p:spPr>
+          <a:xfrm>
+            <a:off x="10488168" y="4133088"/>
+            <a:ext cx="914400" cy="310896"/>
+          </a:xfrm>
+          <a:prstGeom prst="rect">
+            <a:avLst/>
+          </a:prstGeom>
+          <a:noFill/>
+          <a:ln/>
+        </p:spPr>
+        <p:txBody>
+          <a:bodyPr wrap="square" lIns="0" tIns="0" rIns="0" bIns="0" rtlCol="0" anchor="ctr"/>
+          <a:lstStyle/>
+          <a:p>
+            <a:pPr algn="r" indent="0" marL="0">
+              <a:buNone/>
+            </a:pPr>
+            <a:r>
+              <a:rPr lang="en-US" sz="1200" b="1" dirty="0">
+                <a:solidFill>
+                  <a:srgbClr val="5430BF"/>
+                </a:solidFill>
+                <a:latin typeface="DejaVu Sans Mono" pitchFamily="34" charset="0"/>
+                <a:ea typeface="DejaVu Sans Mono" pitchFamily="34" charset="-122"/>
+                <a:cs typeface="DejaVu Sans Mono" pitchFamily="34" charset="-120"/>
+              </a:rPr>
+              <a:t>score</a:t>
+            </a:r>
+            <a:endParaRPr lang="en-US" sz="1200" dirty="0"/>
+          </a:p>
+        </p:txBody>
+      </p:sp>
+      <p:sp>
+        <p:nvSpPr>
+          <p:cNvPr id="46" name="Text 43"/>
+          <p:cNvSpPr txBox="1"/>
+          <p:nvPr/>
+        </p:nvSpPr>
+        <p:spPr>
+          <a:xfrm>
+            <a:off x="8311896" y="4553712"/>
+            <a:ext cx="3090672" cy="365760"/>
+          </a:xfrm>
+          <a:prstGeom prst="rect">
+            <a:avLst/>
+          </a:prstGeom>
+          <a:noFill/>
+          <a:ln/>
+        </p:spPr>
+        <p:txBody>
+          <a:bodyPr wrap="square" lIns="0" tIns="0" rIns="0" bIns="0" rtlCol="0" anchor="t"/>
+          <a:lstStyle/>
+          <a:p>
+            <a:pPr indent="0" marL="0">
+              <a:buNone/>
+            </a:pPr>
+            <a:r>
+              <a:rPr lang="en-US" sz="1700" b="1" dirty="0">
+                <a:solidFill>
+                  <a:srgbClr val="0A0A0A"/>
+                </a:solidFill>
+                <a:latin typeface="Montserrat" pitchFamily="34" charset="0"/>
+                <a:ea typeface="Montserrat" pitchFamily="34" charset="-122"/>
+                <a:cs typeface="Montserrat" pitchFamily="34" charset="-120"/>
+              </a:rPr>
+              <a:t>Auditoria de ligações</a:t>
+            </a:r>
+            <a:endParaRPr lang="en-US" sz="1700" dirty="0"/>
+          </a:p>
+        </p:txBody>
+      </p:sp>
+      <p:sp>
+        <p:nvSpPr>
+          <p:cNvPr id="47" name="Text 44"/>
+          <p:cNvSpPr txBox="1"/>
+          <p:nvPr/>
+        </p:nvSpPr>
+        <p:spPr>
+          <a:xfrm>
+            <a:off x="8311896" y="4937760"/>
+            <a:ext cx="3090672" cy="502920"/>
+          </a:xfrm>
+          <a:prstGeom prst="rect">
+            <a:avLst/>
+          </a:prstGeom>
+          <a:noFill/>
+          <a:ln/>
+        </p:spPr>
+        <p:txBody>
+          <a:bodyPr wrap="square" lIns="0" tIns="0" rIns="0" bIns="0" rtlCol="0" anchor="t"/>
+          <a:lstStyle/>
+          <a:p>
+            <a:pPr indent="0" marL="0">
+              <a:buNone/>
+            </a:pPr>
+            <a:r>
+              <a:rPr lang="en-US" sz="1200" i="1" dirty="0">
+                <a:solidFill>
+                  <a:srgbClr val="5922A5"/>
+                </a:solidFill>
+                <a:latin typeface="Montserrat" pitchFamily="34" charset="0"/>
+                <a:ea typeface="Montserrat" pitchFamily="34" charset="-122"/>
+                <a:cs typeface="Montserrat" pitchFamily="34" charset="-120"/>
+              </a:rPr>
+              <a:t>“O vendedor tratou a objeção de preço?”</a:t>
+            </a:r>
+            <a:endParaRPr lang="en-US" sz="1200" dirty="0"/>
+          </a:p>
+        </p:txBody>
+      </p:sp>
+      <p:sp>
+        <p:nvSpPr>
+          <p:cNvPr id="48" name="Text 45"/>
+          <p:cNvSpPr txBox="1"/>
+          <p:nvPr/>
+        </p:nvSpPr>
+        <p:spPr>
+          <a:xfrm>
+            <a:off x="8311896" y="5440680"/>
+            <a:ext cx="3090672" cy="502920"/>
+          </a:xfrm>
+          <a:prstGeom prst="rect">
+            <a:avLst/>
+          </a:prstGeom>
+          <a:noFill/>
+          <a:ln/>
+        </p:spPr>
+        <p:txBody>
+          <a:bodyPr wrap="square" lIns="0" tIns="0" rIns="0" bIns="0" rtlCol="0" anchor="t"/>
+          <a:lstStyle/>
+          <a:p>
+            <a:pPr indent="0" marL="0">
+              <a:buNone/>
+            </a:pPr>
+            <a:r>
+              <a:rPr lang="en-US" sz="1200" dirty="0">
+                <a:solidFill>
+                  <a:srgbClr val="4B5563"/>
+                </a:solidFill>
+                <a:latin typeface="Montserrat" pitchFamily="34" charset="0"/>
+                <a:ea typeface="Montserrat" pitchFamily="34" charset="-122"/>
+                <a:cs typeface="Montserrat" pitchFamily="34" charset="-120"/>
+              </a:rPr>
+              <a:t>Toda ligação auditada, não só uma amostra.</a:t>
+            </a:r>
+            <a:endParaRPr lang="en-US" sz="1200" dirty="0"/>
+          </a:p>
+        </p:txBody>
+      </p:sp>
+    </p:spTree>
+  </p:cSld>
+  <p:clrMapOvr>
+    <a:masterClrMapping/>
+  </p:clrMapOvr>
+</p:sld>
+</file>
+
+<file path=ppt/slides/slide44.xml><?xml version="1.0" encoding="utf-8"?>
+<p:sld xmlns:a="http://schemas.openxmlformats.org/drawingml/2006/main" xmlns:r="http://schemas.openxmlformats.org/officeDocument/2006/relationships" xmlns:p="http://schemas.openxmlformats.org/presentationml/2006/main">
+  <p:cSld name="Slide 44">
+    <p:bg>
+      <p:bgPr>
+        <a:solidFill>
+          <a:srgbClr val="FAFAFA"/>
+        </a:solidFill>
+      </p:bgPr>
+    </p:bg>
+    <p:spTree>
+      <p:nvGrpSpPr>
+        <p:cNvPr id="1" name=""/>
+        <p:cNvGrpSpPr/>
+        <p:nvPr/>
+      </p:nvGrpSpPr>
+      <p:grpSpPr>
+        <a:xfrm>
+          <a:off x="0" y="0"/>
+          <a:ext cx="0" cy="0"/>
+          <a:chOff x="0" y="0"/>
+          <a:chExt cx="0" cy="0"/>
+        </a:xfrm>
+      </p:grpSpPr>
+      <p:sp>
+        <p:nvSpPr>
+          <p:cNvPr id="2" name="Text 0"/>
+          <p:cNvSpPr txBox="1"/>
+          <p:nvPr/>
+        </p:nvSpPr>
+        <p:spPr>
+          <a:xfrm>
+            <a:off x="548640" y="365760"/>
+            <a:ext cx="8229600" cy="274320"/>
+          </a:xfrm>
+          <a:prstGeom prst="rect">
+            <a:avLst/>
+          </a:prstGeom>
+          <a:noFill/>
+          <a:ln/>
+        </p:spPr>
+        <p:txBody>
+          <a:bodyPr wrap="square" lIns="0" tIns="0" rIns="0" bIns="0" rtlCol="0" anchor="t"/>
+          <a:lstStyle/>
+          <a:p>
+            <a:pPr indent="0" marL="0">
+              <a:buNone/>
+            </a:pPr>
+            <a:r>
+              <a:rPr lang="en-US" sz="1200" b="1" spc="200" kern="0" dirty="0">
+                <a:solidFill>
+                  <a:srgbClr val="5922A5"/>
+                </a:solidFill>
+                <a:latin typeface="Montserrat" pitchFamily="34" charset="0"/>
+                <a:ea typeface="Montserrat" pitchFamily="34" charset="-122"/>
+                <a:cs typeface="Montserrat" pitchFamily="34" charset="-120"/>
+              </a:rPr>
+              <a:t>CASOS DE USO · VANTAGEM TÉCNICA</a:t>
+            </a:r>
+            <a:endParaRPr lang="en-US" sz="1200" dirty="0"/>
+          </a:p>
+        </p:txBody>
+      </p:sp>
+      <p:sp>
+        <p:nvSpPr>
+          <p:cNvPr id="3" name="Text 0"/>
+          <p:cNvSpPr/>
+          <p:nvPr>
+            <p:ph idx="100" type="title" hasCustomPrompt="1"/>
+          </p:nvPr>
+        </p:nvSpPr>
+        <p:spPr>
+          <a:xfrm>
+            <a:off x="548640" y="658368"/>
+            <a:ext cx="9692640" cy="685800"/>
+          </a:xfrm>
+          <a:prstGeom prst="rect">
+            <a:avLst/>
+          </a:prstGeom>
+          <a:noFill/>
+          <a:ln/>
+        </p:spPr>
+        <p:txBody>
+          <a:bodyPr wrap="square" lIns="0" tIns="0" rIns="0" bIns="0" rtlCol="0" anchor="ctr"/>
+          <a:lstStyle/>
+          <a:p>
+            <a:pPr algn="l" indent="0" marL="0">
+              <a:buNone/>
+            </a:pPr>
+            <a:r>
+              <a:rPr lang="en-US" sz="3000" b="1" dirty="0">
+                <a:solidFill>
+                  <a:srgbClr val="0A0A0A"/>
+                </a:solidFill>
+                <a:latin typeface="Montserrat" pitchFamily="34" charset="0"/>
+                <a:ea typeface="Montserrat" pitchFamily="34" charset="-122"/>
+                <a:cs typeface="Montserrat" pitchFamily="34" charset="-120"/>
+              </a:rPr>
+              <a:t>Por que isso vira vantagem competitiva</a:t>
+            </a:r>
+            <a:endParaRPr lang="en-US" sz="3000" dirty="0"/>
+          </a:p>
+        </p:txBody>
+      </p:sp>
+      <p:pic>
+        <p:nvPicPr>
+          <p:cNvPr id="4" name="Image 0" descr="/home/claude/deck/assets/logo.png">    </p:cNvPr>
+          <p:cNvPicPr>
+            <a:picLocks noChangeAspect="1"/>
+          </p:cNvPicPr>
+          <p:nvPr/>
+        </p:nvPicPr>
+        <p:blipFill>
+          <a:blip r:embed="rId1"/>
+          <a:stretch>
+            <a:fillRect/>
+          </a:stretch>
+        </p:blipFill>
+        <p:spPr>
+          <a:xfrm>
+            <a:off x="10515600" y="384048"/>
+            <a:ext cx="1143000" cy="430306"/>
+          </a:xfrm>
+          <a:prstGeom prst="rect">
+            <a:avLst/>
+          </a:prstGeom>
+        </p:spPr>
+      </p:pic>
+      <p:sp>
+        <p:nvSpPr>
+          <p:cNvPr id="5" name="Text 2"/>
+          <p:cNvSpPr txBox="1"/>
+          <p:nvPr/>
+        </p:nvSpPr>
+        <p:spPr>
+          <a:xfrm>
+            <a:off x="548640" y="6419088"/>
+            <a:ext cx="5486400" cy="256032"/>
+          </a:xfrm>
+          <a:prstGeom prst="rect">
+            <a:avLst/>
+          </a:prstGeom>
+          <a:noFill/>
+          <a:ln/>
+        </p:spPr>
+        <p:txBody>
+          <a:bodyPr wrap="square" lIns="0" tIns="0" rIns="0" bIns="0" rtlCol="0" anchor="t"/>
+          <a:lstStyle/>
+          <a:p>
+            <a:pPr indent="0" marL="0">
+              <a:buNone/>
+            </a:pPr>
+            <a:r>
+              <a:rPr lang="en-US" sz="1000" dirty="0">
+                <a:solidFill>
+                  <a:srgbClr val="6B7280"/>
+                </a:solidFill>
+                <a:latin typeface="Montserrat" pitchFamily="34" charset="0"/>
+                <a:ea typeface="Montserrat" pitchFamily="34" charset="-122"/>
+                <a:cs typeface="Montserrat" pitchFamily="34" charset="-120"/>
+              </a:rPr>
+              <a:t>Workshop JEV · WebTech Network</a:t>
+            </a:r>
+            <a:endParaRPr lang="en-US" sz="1000" dirty="0"/>
+          </a:p>
+        </p:txBody>
+      </p:sp>
+      <p:sp>
+        <p:nvSpPr>
+          <p:cNvPr id="6" name="Text 3"/>
+          <p:cNvSpPr txBox="1"/>
+          <p:nvPr/>
+        </p:nvSpPr>
+        <p:spPr>
+          <a:xfrm>
+            <a:off x="11091672" y="6419088"/>
+            <a:ext cx="548640" cy="256032"/>
+          </a:xfrm>
+          <a:prstGeom prst="rect">
+            <a:avLst/>
+          </a:prstGeom>
+          <a:noFill/>
+          <a:ln/>
+        </p:spPr>
+        <p:txBody>
+          <a:bodyPr wrap="square" lIns="0" tIns="0" rIns="0" bIns="0" rtlCol="0" anchor="t"/>
+          <a:lstStyle/>
+          <a:p>
+            <a:pPr algn="r" indent="0" marL="0">
+              <a:buNone/>
+            </a:pPr>
+            <a:r>
+              <a:rPr lang="en-US" sz="1000" dirty="0">
+                <a:solidFill>
+                  <a:srgbClr val="6B7280"/>
+                </a:solidFill>
+                <a:latin typeface="Montserrat" pitchFamily="34" charset="0"/>
+                <a:ea typeface="Montserrat" pitchFamily="34" charset="-122"/>
+                <a:cs typeface="Montserrat" pitchFamily="34" charset="-120"/>
+              </a:rPr>
+              <a:t>44</a:t>
+            </a:r>
+            <a:endParaRPr lang="en-US" sz="1000" dirty="0"/>
+          </a:p>
+        </p:txBody>
+      </p:sp>
+      <p:sp>
+        <p:nvSpPr>
+          <p:cNvPr id="7" name="Shape 4"/>
+          <p:cNvSpPr/>
+          <p:nvPr/>
+        </p:nvSpPr>
+        <p:spPr>
+          <a:xfrm>
+            <a:off x="548640" y="1691640"/>
+            <a:ext cx="3547872" cy="1691640"/>
+          </a:xfrm>
+          <a:prstGeom prst="roundRect">
+            <a:avLst>
+              <a:gd name="adj" fmla="val 7568"/>
+            </a:avLst>
+          </a:prstGeom>
+          <a:solidFill>
+            <a:srgbClr val="FFFFFF"/>
+          </a:solidFill>
+          <a:ln w="12700">
+            <a:solidFill>
+              <a:srgbClr val="E5E7EB"/>
+            </a:solidFill>
+            <a:prstDash val="solid"/>
+          </a:ln>
+        </p:spPr>
+      </p:sp>
+      <p:sp>
+        <p:nvSpPr>
+          <p:cNvPr id="8" name="Text 5"/>
+          <p:cNvSpPr txBox="1"/>
+          <p:nvPr/>
+        </p:nvSpPr>
+        <p:spPr>
+          <a:xfrm>
+            <a:off x="822960" y="1892808"/>
+            <a:ext cx="914400" cy="411480"/>
+          </a:xfrm>
+          <a:prstGeom prst="rect">
+            <a:avLst/>
+          </a:prstGeom>
+          <a:noFill/>
+          <a:ln/>
+        </p:spPr>
+        <p:txBody>
+          <a:bodyPr wrap="square" lIns="0" tIns="0" rIns="0" bIns="0" rtlCol="0" anchor="t"/>
+          <a:lstStyle/>
+          <a:p>
+            <a:pPr indent="0" marL="0">
+              <a:buNone/>
+            </a:pPr>
+            <a:r>
+              <a:rPr lang="en-US" sz="2000" b="1" dirty="0">
+                <a:solidFill>
+                  <a:srgbClr val="5430BF"/>
+                </a:solidFill>
+                <a:latin typeface="Montserrat" pitchFamily="34" charset="0"/>
+                <a:ea typeface="Montserrat" pitchFamily="34" charset="-122"/>
+                <a:cs typeface="Montserrat" pitchFamily="34" charset="-120"/>
+              </a:rPr>
+              <a:t>01</a:t>
+            </a:r>
+            <a:endParaRPr lang="en-US" sz="2000" dirty="0"/>
+          </a:p>
+        </p:txBody>
+      </p:sp>
+      <p:sp>
+        <p:nvSpPr>
+          <p:cNvPr id="9" name="Text 6"/>
+          <p:cNvSpPr txBox="1"/>
+          <p:nvPr/>
+        </p:nvSpPr>
+        <p:spPr>
+          <a:xfrm>
+            <a:off x="822960" y="2286000"/>
+            <a:ext cx="2999232" cy="365760"/>
+          </a:xfrm>
+          <a:prstGeom prst="rect">
+            <a:avLst/>
+          </a:prstGeom>
+          <a:noFill/>
+          <a:ln/>
+        </p:spPr>
+        <p:txBody>
+          <a:bodyPr wrap="square" lIns="0" tIns="0" rIns="0" bIns="0" rtlCol="0" anchor="t"/>
+          <a:lstStyle/>
+          <a:p>
+            <a:pPr indent="0" marL="0">
+              <a:buNone/>
+            </a:pPr>
+            <a:r>
+              <a:rPr lang="en-US" sz="1700" b="1" dirty="0">
+                <a:solidFill>
+                  <a:srgbClr val="0A0A0A"/>
+                </a:solidFill>
+                <a:latin typeface="Montserrat" pitchFamily="34" charset="0"/>
+                <a:ea typeface="Montserrat" pitchFamily="34" charset="-122"/>
+                <a:cs typeface="Montserrat" pitchFamily="34" charset="-120"/>
+              </a:rPr>
+              <a:t>Saída tipada</a:t>
+            </a:r>
+            <a:endParaRPr lang="en-US" sz="1700" dirty="0"/>
+          </a:p>
+        </p:txBody>
+      </p:sp>
+      <p:sp>
+        <p:nvSpPr>
+          <p:cNvPr id="10" name="Text 7"/>
+          <p:cNvSpPr txBox="1"/>
+          <p:nvPr/>
+        </p:nvSpPr>
+        <p:spPr>
+          <a:xfrm>
+            <a:off x="822960" y="2651760"/>
+            <a:ext cx="2999232" cy="685800"/>
+          </a:xfrm>
+          <a:prstGeom prst="rect">
+            <a:avLst/>
+          </a:prstGeom>
+          <a:noFill/>
+          <a:ln/>
+        </p:spPr>
+        <p:txBody>
+          <a:bodyPr wrap="square" lIns="0" tIns="0" rIns="0" bIns="0" rtlCol="0" anchor="t"/>
+          <a:lstStyle/>
+          <a:p>
+            <a:pPr indent="0" marL="0">
+              <a:buNone/>
+            </a:pPr>
+            <a:r>
+              <a:rPr lang="en-US" sz="1200" dirty="0">
+                <a:solidFill>
+                  <a:srgbClr val="4B5563"/>
+                </a:solidFill>
+                <a:latin typeface="Montserrat" pitchFamily="34" charset="0"/>
+                <a:ea typeface="Montserrat" pitchFamily="34" charset="-122"/>
+                <a:cs typeface="Montserrat" pitchFamily="34" charset="-120"/>
+              </a:rPr>
+              <a:t>Integra direto no código. Zero parsing, zero regex em cima de texto livre.</a:t>
+            </a:r>
+            <a:endParaRPr lang="en-US" sz="1200" dirty="0"/>
+          </a:p>
+        </p:txBody>
+      </p:sp>
+      <p:sp>
+        <p:nvSpPr>
+          <p:cNvPr id="11" name="Shape 8"/>
+          <p:cNvSpPr/>
+          <p:nvPr/>
+        </p:nvSpPr>
+        <p:spPr>
+          <a:xfrm>
+            <a:off x="4315968" y="1691640"/>
+            <a:ext cx="3547872" cy="1691640"/>
+          </a:xfrm>
+          <a:prstGeom prst="roundRect">
+            <a:avLst>
+              <a:gd name="adj" fmla="val 7568"/>
+            </a:avLst>
+          </a:prstGeom>
+          <a:solidFill>
+            <a:srgbClr val="FFFFFF"/>
+          </a:solidFill>
+          <a:ln w="12700">
+            <a:solidFill>
+              <a:srgbClr val="E5E7EB"/>
+            </a:solidFill>
+            <a:prstDash val="solid"/>
+          </a:ln>
+        </p:spPr>
+      </p:sp>
+      <p:sp>
+        <p:nvSpPr>
+          <p:cNvPr id="12" name="Text 9"/>
+          <p:cNvSpPr txBox="1"/>
+          <p:nvPr/>
+        </p:nvSpPr>
+        <p:spPr>
+          <a:xfrm>
+            <a:off x="4590288" y="1892808"/>
+            <a:ext cx="914400" cy="411480"/>
+          </a:xfrm>
+          <a:prstGeom prst="rect">
+            <a:avLst/>
+          </a:prstGeom>
+          <a:noFill/>
+          <a:ln/>
+        </p:spPr>
+        <p:txBody>
+          <a:bodyPr wrap="square" lIns="0" tIns="0" rIns="0" bIns="0" rtlCol="0" anchor="t"/>
+          <a:lstStyle/>
+          <a:p>
+            <a:pPr indent="0" marL="0">
+              <a:buNone/>
+            </a:pPr>
+            <a:r>
+              <a:rPr lang="en-US" sz="2000" b="1" dirty="0">
+                <a:solidFill>
+                  <a:srgbClr val="5430BF"/>
+                </a:solidFill>
+                <a:latin typeface="Montserrat" pitchFamily="34" charset="0"/>
+                <a:ea typeface="Montserrat" pitchFamily="34" charset="-122"/>
+                <a:cs typeface="Montserrat" pitchFamily="34" charset="-120"/>
+              </a:rPr>
+              <a:t>02</a:t>
+            </a:r>
+            <a:endParaRPr lang="en-US" sz="2000" dirty="0"/>
+          </a:p>
+        </p:txBody>
+      </p:sp>
+      <p:sp>
+        <p:nvSpPr>
+          <p:cNvPr id="13" name="Text 10"/>
+          <p:cNvSpPr txBox="1"/>
+          <p:nvPr/>
+        </p:nvSpPr>
+        <p:spPr>
+          <a:xfrm>
+            <a:off x="4590288" y="2286000"/>
+            <a:ext cx="2999232" cy="365760"/>
+          </a:xfrm>
+          <a:prstGeom prst="rect">
+            <a:avLst/>
+          </a:prstGeom>
+          <a:noFill/>
+          <a:ln/>
+        </p:spPr>
+        <p:txBody>
+          <a:bodyPr wrap="square" lIns="0" tIns="0" rIns="0" bIns="0" rtlCol="0" anchor="t"/>
+          <a:lstStyle/>
+          <a:p>
+            <a:pPr indent="0" marL="0">
+              <a:buNone/>
+            </a:pPr>
+            <a:r>
+              <a:rPr lang="en-US" sz="1700" b="1" dirty="0">
+                <a:solidFill>
+                  <a:srgbClr val="0A0A0A"/>
+                </a:solidFill>
+                <a:latin typeface="Montserrat" pitchFamily="34" charset="0"/>
+                <a:ea typeface="Montserrat" pitchFamily="34" charset="-122"/>
+                <a:cs typeface="Montserrat" pitchFamily="34" charset="-120"/>
+              </a:rPr>
+              <a:t>Confiança como produto</a:t>
+            </a:r>
+            <a:endParaRPr lang="en-US" sz="1700" dirty="0"/>
+          </a:p>
+        </p:txBody>
+      </p:sp>
+      <p:sp>
+        <p:nvSpPr>
+          <p:cNvPr id="14" name="Text 11"/>
+          <p:cNvSpPr txBox="1"/>
+          <p:nvPr/>
+        </p:nvSpPr>
+        <p:spPr>
+          <a:xfrm>
+            <a:off x="4590288" y="2651760"/>
+            <a:ext cx="2999232" cy="685800"/>
+          </a:xfrm>
+          <a:prstGeom prst="rect">
+            <a:avLst/>
+          </a:prstGeom>
+          <a:noFill/>
+          <a:ln/>
+        </p:spPr>
+        <p:txBody>
+          <a:bodyPr wrap="square" lIns="0" tIns="0" rIns="0" bIns="0" rtlCol="0" anchor="t"/>
+          <a:lstStyle/>
+          <a:p>
+            <a:pPr indent="0" marL="0">
+              <a:buNone/>
+            </a:pPr>
+            <a:r>
+              <a:rPr lang="en-US" sz="1200" dirty="0">
+                <a:solidFill>
+                  <a:srgbClr val="4B5563"/>
+                </a:solidFill>
+                <a:latin typeface="Montserrat" pitchFamily="34" charset="0"/>
+                <a:ea typeface="Montserrat" pitchFamily="34" charset="-122"/>
+                <a:cs typeface="Montserrat" pitchFamily="34" charset="-120"/>
+              </a:rPr>
+              <a:t>O limiar decide o que roda sozinho e o que vai para um humano. Human-in-the-loop calibrado por dados.</a:t>
+            </a:r>
+            <a:endParaRPr lang="en-US" sz="1200" dirty="0"/>
+          </a:p>
+        </p:txBody>
+      </p:sp>
+      <p:sp>
+        <p:nvSpPr>
+          <p:cNvPr id="15" name="Shape 12"/>
+          <p:cNvSpPr/>
+          <p:nvPr/>
+        </p:nvSpPr>
+        <p:spPr>
+          <a:xfrm>
+            <a:off x="8083296" y="1691640"/>
+            <a:ext cx="3547872" cy="1691640"/>
+          </a:xfrm>
+          <a:prstGeom prst="roundRect">
+            <a:avLst>
+              <a:gd name="adj" fmla="val 7568"/>
+            </a:avLst>
+          </a:prstGeom>
+          <a:solidFill>
+            <a:srgbClr val="FFFFFF"/>
+          </a:solidFill>
+          <a:ln w="12700">
+            <a:solidFill>
+              <a:srgbClr val="E5E7EB"/>
+            </a:solidFill>
+            <a:prstDash val="solid"/>
+          </a:ln>
+        </p:spPr>
+      </p:sp>
+      <p:sp>
+        <p:nvSpPr>
+          <p:cNvPr id="16" name="Text 13"/>
+          <p:cNvSpPr txBox="1"/>
+          <p:nvPr/>
+        </p:nvSpPr>
+        <p:spPr>
+          <a:xfrm>
+            <a:off x="8357616" y="1892808"/>
+            <a:ext cx="914400" cy="411480"/>
+          </a:xfrm>
+          <a:prstGeom prst="rect">
+            <a:avLst/>
+          </a:prstGeom>
+          <a:noFill/>
+          <a:ln/>
+        </p:spPr>
+        <p:txBody>
+          <a:bodyPr wrap="square" lIns="0" tIns="0" rIns="0" bIns="0" rtlCol="0" anchor="t"/>
+          <a:lstStyle/>
+          <a:p>
+            <a:pPr indent="0" marL="0">
+              <a:buNone/>
+            </a:pPr>
+            <a:r>
+              <a:rPr lang="en-US" sz="2000" b="1" dirty="0">
+                <a:solidFill>
+                  <a:srgbClr val="5430BF"/>
+                </a:solidFill>
+                <a:latin typeface="Montserrat" pitchFamily="34" charset="0"/>
+                <a:ea typeface="Montserrat" pitchFamily="34" charset="-122"/>
+                <a:cs typeface="Montserrat" pitchFamily="34" charset="-120"/>
+              </a:rPr>
+              <a:t>03</a:t>
+            </a:r>
+            <a:endParaRPr lang="en-US" sz="2000" dirty="0"/>
+          </a:p>
+        </p:txBody>
+      </p:sp>
+      <p:sp>
+        <p:nvSpPr>
+          <p:cNvPr id="17" name="Text 14"/>
+          <p:cNvSpPr txBox="1"/>
+          <p:nvPr/>
+        </p:nvSpPr>
+        <p:spPr>
+          <a:xfrm>
+            <a:off x="8357616" y="2286000"/>
+            <a:ext cx="2999232" cy="365760"/>
+          </a:xfrm>
+          <a:prstGeom prst="rect">
+            <a:avLst/>
+          </a:prstGeom>
+          <a:noFill/>
+          <a:ln/>
+        </p:spPr>
+        <p:txBody>
+          <a:bodyPr wrap="square" lIns="0" tIns="0" rIns="0" bIns="0" rtlCol="0" anchor="t"/>
+          <a:lstStyle/>
+          <a:p>
+            <a:pPr indent="0" marL="0">
+              <a:buNone/>
+            </a:pPr>
+            <a:r>
+              <a:rPr lang="en-US" sz="1700" b="1" dirty="0">
+                <a:solidFill>
+                  <a:srgbClr val="0A0A0A"/>
+                </a:solidFill>
+                <a:latin typeface="Montserrat" pitchFamily="34" charset="0"/>
+                <a:ea typeface="Montserrat" pitchFamily="34" charset="-122"/>
+                <a:cs typeface="Montserrat" pitchFamily="34" charset="-120"/>
+              </a:rPr>
+              <a:t>Regra de negócio é dado</a:t>
+            </a:r>
+            <a:endParaRPr lang="en-US" sz="1700" dirty="0"/>
+          </a:p>
+        </p:txBody>
+      </p:sp>
+      <p:sp>
+        <p:nvSpPr>
+          <p:cNvPr id="18" name="Text 15"/>
+          <p:cNvSpPr txBox="1"/>
+          <p:nvPr/>
+        </p:nvSpPr>
+        <p:spPr>
+          <a:xfrm>
+            <a:off x="8357616" y="2651760"/>
+            <a:ext cx="2999232" cy="685800"/>
+          </a:xfrm>
+          <a:prstGeom prst="rect">
+            <a:avLst/>
+          </a:prstGeom>
+          <a:noFill/>
+          <a:ln/>
+        </p:spPr>
+        <p:txBody>
+          <a:bodyPr wrap="square" lIns="0" tIns="0" rIns="0" bIns="0" rtlCol="0" anchor="t"/>
+          <a:lstStyle/>
+          <a:p>
+            <a:pPr indent="0" marL="0">
+              <a:buNone/>
+            </a:pPr>
+            <a:r>
+              <a:rPr lang="en-US" sz="1200" dirty="0">
+                <a:solidFill>
+                  <a:srgbClr val="4B5563"/>
+                </a:solidFill>
+                <a:latin typeface="Montserrat" pitchFamily="34" charset="0"/>
+                <a:ea typeface="Montserrat" pitchFamily="34" charset="-122"/>
+                <a:cs typeface="Montserrat" pitchFamily="34" charset="-120"/>
+              </a:rPr>
+              <a:t>A rubrica é um JSON. O time de negócio muda o critério sem deploy.</a:t>
+            </a:r>
+            <a:endParaRPr lang="en-US" sz="1200" dirty="0"/>
+          </a:p>
+        </p:txBody>
+      </p:sp>
+      <p:sp>
+        <p:nvSpPr>
+          <p:cNvPr id="19" name="Shape 16"/>
+          <p:cNvSpPr/>
+          <p:nvPr/>
+        </p:nvSpPr>
+        <p:spPr>
+          <a:xfrm>
+            <a:off x="548640" y="3520440"/>
+            <a:ext cx="3547872" cy="1691640"/>
+          </a:xfrm>
+          <a:prstGeom prst="roundRect">
+            <a:avLst>
+              <a:gd name="adj" fmla="val 7568"/>
+            </a:avLst>
+          </a:prstGeom>
+          <a:solidFill>
+            <a:srgbClr val="EBE7F5"/>
+          </a:solidFill>
+          <a:ln w="12700">
+            <a:solidFill>
+              <a:srgbClr val="EBE7F5"/>
+            </a:solidFill>
+            <a:prstDash val="solid"/>
+          </a:ln>
+        </p:spPr>
+      </p:sp>
+      <p:sp>
+        <p:nvSpPr>
+          <p:cNvPr id="20" name="Text 17"/>
+          <p:cNvSpPr txBox="1"/>
+          <p:nvPr/>
+        </p:nvSpPr>
+        <p:spPr>
+          <a:xfrm>
+            <a:off x="822960" y="3721608"/>
+            <a:ext cx="914400" cy="411480"/>
+          </a:xfrm>
+          <a:prstGeom prst="rect">
+            <a:avLst/>
+          </a:prstGeom>
+          <a:noFill/>
+          <a:ln/>
+        </p:spPr>
+        <p:txBody>
+          <a:bodyPr wrap="square" lIns="0" tIns="0" rIns="0" bIns="0" rtlCol="0" anchor="t"/>
+          <a:lstStyle/>
+          <a:p>
+            <a:pPr indent="0" marL="0">
+              <a:buNone/>
+            </a:pPr>
+            <a:r>
+              <a:rPr lang="en-US" sz="2000" b="1" dirty="0">
+                <a:solidFill>
+                  <a:srgbClr val="5430BF"/>
+                </a:solidFill>
+                <a:latin typeface="Montserrat" pitchFamily="34" charset="0"/>
+                <a:ea typeface="Montserrat" pitchFamily="34" charset="-122"/>
+                <a:cs typeface="Montserrat" pitchFamily="34" charset="-120"/>
+              </a:rPr>
+              <a:t>04</a:t>
+            </a:r>
+            <a:endParaRPr lang="en-US" sz="2000" dirty="0"/>
+          </a:p>
+        </p:txBody>
+      </p:sp>
+      <p:sp>
+        <p:nvSpPr>
+          <p:cNvPr id="21" name="Text 18"/>
+          <p:cNvSpPr txBox="1"/>
+          <p:nvPr/>
+        </p:nvSpPr>
+        <p:spPr>
+          <a:xfrm>
+            <a:off x="822960" y="4114800"/>
+            <a:ext cx="2999232" cy="365760"/>
+          </a:xfrm>
+          <a:prstGeom prst="rect">
+            <a:avLst/>
+          </a:prstGeom>
+          <a:noFill/>
+          <a:ln/>
+        </p:spPr>
+        <p:txBody>
+          <a:bodyPr wrap="square" lIns="0" tIns="0" rIns="0" bIns="0" rtlCol="0" anchor="t"/>
+          <a:lstStyle/>
+          <a:p>
+            <a:pPr indent="0" marL="0">
+              <a:buNone/>
+            </a:pPr>
+            <a:r>
+              <a:rPr lang="en-US" sz="1700" b="1" dirty="0">
+                <a:solidFill>
+                  <a:srgbClr val="0A0A0A"/>
+                </a:solidFill>
+                <a:latin typeface="Montserrat" pitchFamily="34" charset="0"/>
+                <a:ea typeface="Montserrat" pitchFamily="34" charset="-122"/>
+                <a:cs typeface="Montserrat" pitchFamily="34" charset="-120"/>
+              </a:rPr>
+              <a:t>Auditável</a:t>
+            </a:r>
+            <a:endParaRPr lang="en-US" sz="1700" dirty="0"/>
+          </a:p>
+        </p:txBody>
+      </p:sp>
+      <p:sp>
+        <p:nvSpPr>
+          <p:cNvPr id="22" name="Text 19"/>
+          <p:cNvSpPr txBox="1"/>
+          <p:nvPr/>
+        </p:nvSpPr>
+        <p:spPr>
+          <a:xfrm>
+            <a:off x="822960" y="4480560"/>
+            <a:ext cx="2999232" cy="685800"/>
+          </a:xfrm>
+          <a:prstGeom prst="rect">
+            <a:avLst/>
+          </a:prstGeom>
+          <a:noFill/>
+          <a:ln/>
+        </p:spPr>
+        <p:txBody>
+          <a:bodyPr wrap="square" lIns="0" tIns="0" rIns="0" bIns="0" rtlCol="0" anchor="t"/>
+          <a:lstStyle/>
+          <a:p>
+            <a:pPr indent="0" marL="0">
+              <a:buNone/>
+            </a:pPr>
+            <a:r>
+              <a:rPr lang="en-US" sz="1200" dirty="0">
+                <a:solidFill>
+                  <a:srgbClr val="4B5563"/>
+                </a:solidFill>
+                <a:latin typeface="Montserrat" pitchFamily="34" charset="0"/>
+                <a:ea typeface="Montserrat" pitchFamily="34" charset="-122"/>
+                <a:cs typeface="Montserrat" pitchFamily="34" charset="-120"/>
+              </a:rPr>
+              <a:t>Cada decisão guarda a distribuição de probabilidades. Dá para explicar e reprocessar qualquer leitura.</a:t>
+            </a:r>
+            <a:endParaRPr lang="en-US" sz="1200" dirty="0"/>
+          </a:p>
+        </p:txBody>
+      </p:sp>
+      <p:sp>
+        <p:nvSpPr>
+          <p:cNvPr id="23" name="Shape 20"/>
+          <p:cNvSpPr/>
+          <p:nvPr/>
+        </p:nvSpPr>
+        <p:spPr>
+          <a:xfrm>
+            <a:off x="4315968" y="3520440"/>
+            <a:ext cx="3547872" cy="1691640"/>
+          </a:xfrm>
+          <a:prstGeom prst="roundRect">
+            <a:avLst>
+              <a:gd name="adj" fmla="val 7568"/>
+            </a:avLst>
+          </a:prstGeom>
+          <a:solidFill>
+            <a:srgbClr val="EBE7F5"/>
+          </a:solidFill>
+          <a:ln w="12700">
+            <a:solidFill>
+              <a:srgbClr val="EBE7F5"/>
+            </a:solidFill>
+            <a:prstDash val="solid"/>
+          </a:ln>
+        </p:spPr>
+      </p:sp>
+      <p:sp>
+        <p:nvSpPr>
+          <p:cNvPr id="24" name="Text 21"/>
+          <p:cNvSpPr txBox="1"/>
+          <p:nvPr/>
+        </p:nvSpPr>
+        <p:spPr>
+          <a:xfrm>
+            <a:off x="4590288" y="3721608"/>
+            <a:ext cx="914400" cy="411480"/>
+          </a:xfrm>
+          <a:prstGeom prst="rect">
+            <a:avLst/>
+          </a:prstGeom>
+          <a:noFill/>
+          <a:ln/>
+        </p:spPr>
+        <p:txBody>
+          <a:bodyPr wrap="square" lIns="0" tIns="0" rIns="0" bIns="0" rtlCol="0" anchor="t"/>
+          <a:lstStyle/>
+          <a:p>
+            <a:pPr indent="0" marL="0">
+              <a:buNone/>
+            </a:pPr>
+            <a:r>
+              <a:rPr lang="en-US" sz="2000" b="1" dirty="0">
+                <a:solidFill>
+                  <a:srgbClr val="5430BF"/>
+                </a:solidFill>
+                <a:latin typeface="Montserrat" pitchFamily="34" charset="0"/>
+                <a:ea typeface="Montserrat" pitchFamily="34" charset="-122"/>
+                <a:cs typeface="Montserrat" pitchFamily="34" charset="-120"/>
+              </a:rPr>
+              <a:t>05</a:t>
+            </a:r>
+            <a:endParaRPr lang="en-US" sz="2000" dirty="0"/>
+          </a:p>
+        </p:txBody>
+      </p:sp>
+      <p:sp>
+        <p:nvSpPr>
+          <p:cNvPr id="25" name="Text 22"/>
+          <p:cNvSpPr txBox="1"/>
+          <p:nvPr/>
+        </p:nvSpPr>
+        <p:spPr>
+          <a:xfrm>
+            <a:off x="4590288" y="4114800"/>
+            <a:ext cx="2999232" cy="365760"/>
+          </a:xfrm>
+          <a:prstGeom prst="rect">
+            <a:avLst/>
+          </a:prstGeom>
+          <a:noFill/>
+          <a:ln/>
+        </p:spPr>
+        <p:txBody>
+          <a:bodyPr wrap="square" lIns="0" tIns="0" rIns="0" bIns="0" rtlCol="0" anchor="t"/>
+          <a:lstStyle/>
+          <a:p>
+            <a:pPr indent="0" marL="0">
+              <a:buNone/>
+            </a:pPr>
+            <a:r>
+              <a:rPr lang="en-US" sz="1700" b="1" dirty="0">
+                <a:solidFill>
+                  <a:srgbClr val="0A0A0A"/>
+                </a:solidFill>
+                <a:latin typeface="Montserrat" pitchFamily="34" charset="0"/>
+                <a:ea typeface="Montserrat" pitchFamily="34" charset="-122"/>
+                <a:cs typeface="Montserrat" pitchFamily="34" charset="-120"/>
+              </a:rPr>
+              <a:t>Custo previsível</a:t>
+            </a:r>
+            <a:endParaRPr lang="en-US" sz="1700" dirty="0"/>
+          </a:p>
+        </p:txBody>
+      </p:sp>
+      <p:sp>
+        <p:nvSpPr>
+          <p:cNvPr id="26" name="Text 23"/>
+          <p:cNvSpPr txBox="1"/>
+          <p:nvPr/>
+        </p:nvSpPr>
+        <p:spPr>
+          <a:xfrm>
+            <a:off x="4590288" y="4480560"/>
+            <a:ext cx="2999232" cy="685800"/>
+          </a:xfrm>
+          <a:prstGeom prst="rect">
+            <a:avLst/>
+          </a:prstGeom>
+          <a:noFill/>
+          <a:ln/>
+        </p:spPr>
+        <p:txBody>
+          <a:bodyPr wrap="square" lIns="0" tIns="0" rIns="0" bIns="0" rtlCol="0" anchor="t"/>
+          <a:lstStyle/>
+          <a:p>
+            <a:pPr indent="0" marL="0">
+              <a:buNone/>
+            </a:pPr>
+            <a:r>
+              <a:rPr lang="en-US" sz="1200" dirty="0">
+                <a:solidFill>
+                  <a:srgbClr val="4B5563"/>
+                </a:solidFill>
+                <a:latin typeface="Montserrat" pitchFamily="34" charset="0"/>
+                <a:ea typeface="Montserrat" pitchFamily="34" charset="-122"/>
+                <a:cs typeface="Montserrat" pitchFamily="34" charset="-120"/>
+              </a:rPr>
+              <a:t>Uma chamada responde várias perguntas, por frações de centavo.</a:t>
+            </a:r>
+            <a:endParaRPr lang="en-US" sz="1200" dirty="0"/>
+          </a:p>
+        </p:txBody>
+      </p:sp>
+      <p:sp>
+        <p:nvSpPr>
+          <p:cNvPr id="27" name="Shape 24"/>
+          <p:cNvSpPr/>
+          <p:nvPr/>
+        </p:nvSpPr>
+        <p:spPr>
+          <a:xfrm>
+            <a:off x="8083296" y="3520440"/>
+            <a:ext cx="3547872" cy="1691640"/>
+          </a:xfrm>
+          <a:prstGeom prst="roundRect">
+            <a:avLst>
+              <a:gd name="adj" fmla="val 7568"/>
+            </a:avLst>
+          </a:prstGeom>
+          <a:solidFill>
+            <a:srgbClr val="EBE7F5"/>
+          </a:solidFill>
+          <a:ln w="12700">
+            <a:solidFill>
+              <a:srgbClr val="EBE7F5"/>
+            </a:solidFill>
+            <a:prstDash val="solid"/>
+          </a:ln>
+        </p:spPr>
+      </p:sp>
+      <p:sp>
+        <p:nvSpPr>
+          <p:cNvPr id="28" name="Text 25"/>
+          <p:cNvSpPr txBox="1"/>
+          <p:nvPr/>
+        </p:nvSpPr>
+        <p:spPr>
+          <a:xfrm>
+            <a:off x="8357616" y="3721608"/>
+            <a:ext cx="914400" cy="411480"/>
+          </a:xfrm>
+          <a:prstGeom prst="rect">
+            <a:avLst/>
+          </a:prstGeom>
+          <a:noFill/>
+          <a:ln/>
+        </p:spPr>
+        <p:txBody>
+          <a:bodyPr wrap="square" lIns="0" tIns="0" rIns="0" bIns="0" rtlCol="0" anchor="t"/>
+          <a:lstStyle/>
+          <a:p>
+            <a:pPr indent="0" marL="0">
+              <a:buNone/>
+            </a:pPr>
+            <a:r>
+              <a:rPr lang="en-US" sz="2000" b="1" dirty="0">
+                <a:solidFill>
+                  <a:srgbClr val="5430BF"/>
+                </a:solidFill>
+                <a:latin typeface="Montserrat" pitchFamily="34" charset="0"/>
+                <a:ea typeface="Montserrat" pitchFamily="34" charset="-122"/>
+                <a:cs typeface="Montserrat" pitchFamily="34" charset="-120"/>
+              </a:rPr>
+              <a:t>06</a:t>
+            </a:r>
+            <a:endParaRPr lang="en-US" sz="2000" dirty="0"/>
+          </a:p>
+        </p:txBody>
+      </p:sp>
+      <p:sp>
+        <p:nvSpPr>
+          <p:cNvPr id="29" name="Text 26"/>
+          <p:cNvSpPr txBox="1"/>
+          <p:nvPr/>
+        </p:nvSpPr>
+        <p:spPr>
+          <a:xfrm>
+            <a:off x="8357616" y="4114800"/>
+            <a:ext cx="2999232" cy="365760"/>
+          </a:xfrm>
+          <a:prstGeom prst="rect">
+            <a:avLst/>
+          </a:prstGeom>
+          <a:noFill/>
+          <a:ln/>
+        </p:spPr>
+        <p:txBody>
+          <a:bodyPr wrap="square" lIns="0" tIns="0" rIns="0" bIns="0" rtlCol="0" anchor="t"/>
+          <a:lstStyle/>
+          <a:p>
+            <a:pPr indent="0" marL="0">
+              <a:buNone/>
+            </a:pPr>
+            <a:r>
+              <a:rPr lang="en-US" sz="1700" b="1" dirty="0">
+                <a:solidFill>
+                  <a:srgbClr val="0A0A0A"/>
+                </a:solidFill>
+                <a:latin typeface="Montserrat" pitchFamily="34" charset="0"/>
+                <a:ea typeface="Montserrat" pitchFamily="34" charset="-122"/>
+                <a:cs typeface="Montserrat" pitchFamily="34" charset="-120"/>
+              </a:rPr>
+              <a:t>Roda na sua infra</a:t>
+            </a:r>
+            <a:endParaRPr lang="en-US" sz="1700" dirty="0"/>
+          </a:p>
+        </p:txBody>
+      </p:sp>
+      <p:sp>
+        <p:nvSpPr>
+          <p:cNvPr id="30" name="Text 27"/>
+          <p:cNvSpPr txBox="1"/>
+          <p:nvPr/>
+        </p:nvSpPr>
+        <p:spPr>
+          <a:xfrm>
+            <a:off x="8357616" y="4480560"/>
+            <a:ext cx="2999232" cy="685800"/>
+          </a:xfrm>
+          <a:prstGeom prst="rect">
+            <a:avLst/>
+          </a:prstGeom>
+          <a:noFill/>
+          <a:ln/>
+        </p:spPr>
+        <p:txBody>
+          <a:bodyPr wrap="square" lIns="0" tIns="0" rIns="0" bIns="0" rtlCol="0" anchor="t"/>
+          <a:lstStyle/>
+          <a:p>
+            <a:pPr indent="0" marL="0">
+              <a:buNone/>
+            </a:pPr>
+            <a:r>
+              <a:rPr lang="en-US" sz="1200" dirty="0">
+                <a:solidFill>
+                  <a:srgbClr val="4B5563"/>
+                </a:solidFill>
+                <a:latin typeface="Montserrat" pitchFamily="34" charset="0"/>
+                <a:ea typeface="Montserrat" pitchFamily="34" charset="-122"/>
+                <a:cs typeface="Montserrat" pitchFamily="34" charset="-120"/>
+              </a:rPr>
+              <a:t>Open-Jev, réplica open source em Docker (2B a 27B), para dados que não podem sair de casa. Precisa de GPU.</a:t>
+            </a:r>
+            <a:endParaRPr lang="en-US" sz="1200" dirty="0"/>
+          </a:p>
+        </p:txBody>
+      </p:sp>
+      <p:sp>
+        <p:nvSpPr>
+          <p:cNvPr id="31" name="Shape 28"/>
+          <p:cNvSpPr/>
+          <p:nvPr/>
+        </p:nvSpPr>
+        <p:spPr>
+          <a:xfrm>
+            <a:off x="548640" y="5440680"/>
+            <a:ext cx="11091672" cy="685800"/>
+          </a:xfrm>
+          <a:prstGeom prst="roundRect">
+            <a:avLst>
+              <a:gd name="adj" fmla="val 18667"/>
+            </a:avLst>
+          </a:prstGeom>
+          <a:solidFill>
+            <a:srgbClr val="FFC31A"/>
+          </a:solidFill>
+          <a:ln w="12700">
+            <a:solidFill>
+              <a:srgbClr val="FFC31A"/>
+            </a:solidFill>
+            <a:prstDash val="solid"/>
+          </a:ln>
+        </p:spPr>
+      </p:sp>
+      <p:sp>
+        <p:nvSpPr>
+          <p:cNvPr id="32" name="Text 29"/>
+          <p:cNvSpPr txBox="1"/>
+          <p:nvPr/>
+        </p:nvSpPr>
+        <p:spPr>
+          <a:xfrm>
+            <a:off x="868680" y="5440680"/>
+            <a:ext cx="10424160" cy="685800"/>
+          </a:xfrm>
+          <a:prstGeom prst="rect">
+            <a:avLst/>
+          </a:prstGeom>
+          <a:noFill/>
+          <a:ln/>
+        </p:spPr>
+        <p:txBody>
+          <a:bodyPr wrap="square" lIns="0" tIns="0" rIns="0" bIns="0" rtlCol="0" anchor="ctr"/>
+          <a:lstStyle/>
+          <a:p>
+            <a:pPr indent="0" marL="0">
+              <a:buNone/>
+            </a:pPr>
+            <a:r>
+              <a:rPr lang="en-US" sz="1600" b="1" dirty="0">
+                <a:solidFill>
+                  <a:srgbClr val="0A0A0A"/>
+                </a:solidFill>
+                <a:latin typeface="Montserrat" pitchFamily="34" charset="0"/>
+                <a:ea typeface="Montserrat" pitchFamily="34" charset="-122"/>
+                <a:cs typeface="Montserrat" pitchFamily="34" charset="-120"/>
+              </a:rPr>
+              <a:t>E o que você treinou hoje — baseline, calibração, limiar — é o que separa um piloto de IA de um produto que dá dinheiro.</a:t>
+            </a:r>
+            <a:endParaRPr lang="en-US" sz="1600" dirty="0"/>
+          </a:p>
+        </p:txBody>
+      </p:sp>
+    </p:spTree>
+  </p:cSld>
+  <p:clrMapOvr>
+    <a:masterClrMapping/>
+  </p:clrMapOvr>
+</p:sld>
+</file>
+
+<file path=ppt/slides/slide45.xml><?xml version="1.0" encoding="utf-8"?>
+<p:sld xmlns:a="http://schemas.openxmlformats.org/drawingml/2006/main" xmlns:r="http://schemas.openxmlformats.org/officeDocument/2006/relationships" xmlns:p="http://schemas.openxmlformats.org/presentationml/2006/main">
+  <p:cSld name="Slide 45">
+    <p:bg>
+      <p:bgPr>
         <a:blipFill dpi="0" rotWithShape="1">
           <a:blip r:embed="rId1">
             <a:lum/>

</xml_diff>